<commit_message>
Remove requested slides from GreatPM submission deck
</commit_message>
<xml_diff>
--- a/docs/submission/Assignment 4 - Vandana Ajay Dubey C51.pptx
+++ b/docs/submission/Assignment 4 - Vandana Ajay Dubey C51.pptx
@@ -2,25 +2,22 @@
 <file path=ppt/presentation.xml><?xml version="1.0" encoding="utf-8"?>
 <p:presentation xmlns:p="http://schemas.openxmlformats.org/presentationml/2006/main">
   <p:sldMasterIdLst>
-    <p:sldMasterId xmlns:r="http://schemas.openxmlformats.org/officeDocument/2006/relationships" id="2147483648" r:id="R2c83493dbb684098"/>
+    <p:sldMasterId xmlns:r="http://schemas.openxmlformats.org/officeDocument/2006/relationships" id="2147483648" r:id="R651d5c3bbf334e55"/>
   </p:sldMasterIdLst>
   <p:notesMasterIdLst>
-    <p:notesMasterId xmlns:r="http://schemas.openxmlformats.org/officeDocument/2006/relationships" r:id="R31be0d2eff3a4fb8"/>
+    <p:notesMasterId xmlns:r="http://schemas.openxmlformats.org/officeDocument/2006/relationships" r:id="R99b889b07ae24eda"/>
   </p:notesMasterIdLst>
   <p:sldIdLst>
-    <p:sldId xmlns:r="http://schemas.openxmlformats.org/officeDocument/2006/relationships" id="256" r:id="R5acc0e6955ae4b33"/>
-    <p:sldId xmlns:r="http://schemas.openxmlformats.org/officeDocument/2006/relationships" id="257" r:id="Rd8a60405536b4003"/>
-    <p:sldId xmlns:r="http://schemas.openxmlformats.org/officeDocument/2006/relationships" id="258" r:id="R6ad78517e8c64269"/>
-    <p:sldId xmlns:r="http://schemas.openxmlformats.org/officeDocument/2006/relationships" id="259" r:id="Rc431fee82d0f4ba2"/>
-    <p:sldId xmlns:r="http://schemas.openxmlformats.org/officeDocument/2006/relationships" id="260" r:id="R5d490ad29ff04554"/>
-    <p:sldId xmlns:r="http://schemas.openxmlformats.org/officeDocument/2006/relationships" id="261" r:id="R59e23cf74f65409f"/>
-    <p:sldId xmlns:r="http://schemas.openxmlformats.org/officeDocument/2006/relationships" id="262" r:id="R5b2796786d2d48a2"/>
-    <p:sldId xmlns:r="http://schemas.openxmlformats.org/officeDocument/2006/relationships" id="263" r:id="R501b089b3dd849a3"/>
-    <p:sldId xmlns:r="http://schemas.openxmlformats.org/officeDocument/2006/relationships" id="264" r:id="Re7889909b06b4be1"/>
-    <p:sldId xmlns:r="http://schemas.openxmlformats.org/officeDocument/2006/relationships" id="265" r:id="R50951b6f41fc4855"/>
-    <p:sldId xmlns:r="http://schemas.openxmlformats.org/officeDocument/2006/relationships" id="266" r:id="Rc6f1aa2027cb4bfb"/>
-    <p:sldId xmlns:r="http://schemas.openxmlformats.org/officeDocument/2006/relationships" id="267" r:id="R42aa28db1b83432f"/>
-    <p:sldId xmlns:r="http://schemas.openxmlformats.org/officeDocument/2006/relationships" id="268" r:id="Ra167c92d53e34f44"/>
+    <p:sldId xmlns:r="http://schemas.openxmlformats.org/officeDocument/2006/relationships" id="256" r:id="R87c849d22ff74966"/>
+    <p:sldId xmlns:r="http://schemas.openxmlformats.org/officeDocument/2006/relationships" id="257" r:id="Raf2861095a674e9f"/>
+    <p:sldId xmlns:r="http://schemas.openxmlformats.org/officeDocument/2006/relationships" id="258" r:id="R45209f1355f241fe"/>
+    <p:sldId xmlns:r="http://schemas.openxmlformats.org/officeDocument/2006/relationships" id="259" r:id="R445b543cd5544438"/>
+    <p:sldId xmlns:r="http://schemas.openxmlformats.org/officeDocument/2006/relationships" id="260" r:id="Rdaf33558883d4710"/>
+    <p:sldId xmlns:r="http://schemas.openxmlformats.org/officeDocument/2006/relationships" id="261" r:id="R95d09fa5e8d8476b"/>
+    <p:sldId xmlns:r="http://schemas.openxmlformats.org/officeDocument/2006/relationships" id="262" r:id="R17c493118b29421b"/>
+    <p:sldId xmlns:r="http://schemas.openxmlformats.org/officeDocument/2006/relationships" id="263" r:id="R8cc3aa9c47354fdf"/>
+    <p:sldId xmlns:r="http://schemas.openxmlformats.org/officeDocument/2006/relationships" id="264" r:id="R30ae48f5743e4d6f"/>
+    <p:sldId xmlns:r="http://schemas.openxmlformats.org/officeDocument/2006/relationships" id="265" r:id="Rfa8f4467d6da4be8"/>
   </p:sldIdLst>
   <p:sldSz cx="12192000" cy="6858000"/>
   <p:notesSz cx="6858000" cy="9144000"/>
@@ -524,217 +521,7 @@
           <a:lstStyle xmlns:a="http://schemas.openxmlformats.org/drawingml/2006/main"/>
           <a:p xmlns:a="http://schemas.openxmlformats.org/drawingml/2006/main">
             <a:r>
-              <a:t>Sources: https://github.com/VandanaAjayDubey111/great-pm/pull/3, docs/MCP-ARCHITECTURE.md, docs/MCP.md, PRIVACY.md; https://github.com/VandanaAjayDubey111/great-pm/blob/main/LICENSE. Host/model provider data policies still apply to native usage. Public MCP is authless, stateless and read-only, with no model calls, outbound requests, project access or external writes. Do not send confidential or personal data in public MCP arguments. MIT does not imply zero model, tool or hosting cost.</a:t>
-            </a:r>
-          </a:p>
-        </p:txBody>
-      </p:sp>
-      <p:sp>
-        <p:nvSpPr>
-          <p:cNvPr id="4" name="Slide Number Placeholder 3"/>
-          <p:cNvSpPr>
-            <a:spLocks xmlns:a="http://schemas.openxmlformats.org/drawingml/2006/main" noGrp="1"/>
-          </p:cNvSpPr>
-          <p:nvPr>
-            <p:ph type="sldNum" idx="5"/>
-          </p:nvPr>
-        </p:nvSpPr>
-        <p:spPr/>
-        <p:txBody>
-          <a:bodyPr xmlns:a="http://schemas.openxmlformats.org/drawingml/2006/main"/>
-          <a:lstStyle xmlns:a="http://schemas.openxmlformats.org/drawingml/2006/main"/>
-          <a:p xmlns:a="http://schemas.openxmlformats.org/drawingml/2006/main"/>
-        </p:txBody>
-      </p:sp>
-    </p:spTree>
-  </p:cSld>
-  <p:clrMapOvr>
-    <a:masterClrMapping xmlns:a="http://schemas.openxmlformats.org/drawingml/2006/main"/>
-  </p:clrMapOvr>
-</p:notes>
-</file>
-
-<file path=ppt/notesSlides/notesSlide11.xml><?xml version="1.0" encoding="utf-8"?>
-<p:notes xmlns:p="http://schemas.openxmlformats.org/presentationml/2006/main">
-  <p:cSld>
-    <p:spTree>
-      <p:nvGrpSpPr>
-        <p:cNvPr id="1" name=""/>
-        <p:cNvGrpSpPr/>
-        <p:nvPr/>
-      </p:nvGrpSpPr>
-      <p:grpSpPr>
-        <a:xfrm xmlns:a="http://schemas.openxmlformats.org/drawingml/2006/main"/>
-      </p:grpSpPr>
-      <p:sp>
-        <p:nvSpPr>
-          <p:cNvPr id="2" name="Slide Image Placeholder 1"/>
-          <p:cNvSpPr>
-            <a:spLocks xmlns:a="http://schemas.openxmlformats.org/drawingml/2006/main" noGrp="1"/>
-          </p:cNvSpPr>
-          <p:nvPr>
-            <p:ph type="sldImg" idx="0"/>
-          </p:nvPr>
-        </p:nvSpPr>
-        <p:spPr/>
-      </p:sp>
-      <p:sp>
-        <p:nvSpPr>
-          <p:cNvPr id="3" name="Notes Placeholder 2"/>
-          <p:cNvSpPr>
-            <a:spLocks xmlns:a="http://schemas.openxmlformats.org/drawingml/2006/main" noGrp="1"/>
-          </p:cNvSpPr>
-          <p:nvPr>
-            <p:ph type="body" idx="1"/>
-          </p:nvPr>
-        </p:nvSpPr>
-        <p:spPr/>
-        <p:txBody>
-          <a:bodyPr xmlns:a="http://schemas.openxmlformats.org/drawingml/2006/main"/>
-          <a:lstStyle xmlns:a="http://schemas.openxmlformats.org/drawingml/2006/main"/>
-          <a:p xmlns:a="http://schemas.openxmlformats.org/drawingml/2006/main">
-            <a:r>
-              <a:t>Creator/user feedback in project conversation, Jul-Sep 2026. One person, repeated observations, not five interviews. Summarized private feedback, no direct quotes. This is creator experience, not independent market validation. Native experience gaps versus MCP, grill/grill-me naming inconsistency after reinstall and repeated setup/approval friction informed full Codex packaging, $grill-me naming preservation and clearer plugin/MCP boundaries. Setup friction remains a learning priority.</a:t>
-            </a:r>
-          </a:p>
-        </p:txBody>
-      </p:sp>
-      <p:sp>
-        <p:nvSpPr>
-          <p:cNvPr id="4" name="Slide Number Placeholder 3"/>
-          <p:cNvSpPr>
-            <a:spLocks xmlns:a="http://schemas.openxmlformats.org/drawingml/2006/main" noGrp="1"/>
-          </p:cNvSpPr>
-          <p:nvPr>
-            <p:ph type="sldNum" idx="5"/>
-          </p:nvPr>
-        </p:nvSpPr>
-        <p:spPr/>
-        <p:txBody>
-          <a:bodyPr xmlns:a="http://schemas.openxmlformats.org/drawingml/2006/main"/>
-          <a:lstStyle xmlns:a="http://schemas.openxmlformats.org/drawingml/2006/main"/>
-          <a:p xmlns:a="http://schemas.openxmlformats.org/drawingml/2006/main"/>
-        </p:txBody>
-      </p:sp>
-    </p:spTree>
-  </p:cSld>
-  <p:clrMapOvr>
-    <a:masterClrMapping xmlns:a="http://schemas.openxmlformats.org/drawingml/2006/main"/>
-  </p:clrMapOvr>
-</p:notes>
-</file>
-
-<file path=ppt/notesSlides/notesSlide12.xml><?xml version="1.0" encoding="utf-8"?>
-<p:notes xmlns:p="http://schemas.openxmlformats.org/presentationml/2006/main">
-  <p:cSld>
-    <p:spTree>
-      <p:nvGrpSpPr>
-        <p:cNvPr id="1" name=""/>
-        <p:cNvGrpSpPr/>
-        <p:nvPr/>
-      </p:nvGrpSpPr>
-      <p:grpSpPr>
-        <a:xfrm xmlns:a="http://schemas.openxmlformats.org/drawingml/2006/main"/>
-      </p:grpSpPr>
-      <p:sp>
-        <p:nvSpPr>
-          <p:cNvPr id="2" name="Slide Image Placeholder 1"/>
-          <p:cNvSpPr>
-            <a:spLocks xmlns:a="http://schemas.openxmlformats.org/drawingml/2006/main" noGrp="1"/>
-          </p:cNvSpPr>
-          <p:nvPr>
-            <p:ph type="sldImg" idx="0"/>
-          </p:nvPr>
-        </p:nvSpPr>
-        <p:spPr/>
-      </p:sp>
-      <p:sp>
-        <p:nvSpPr>
-          <p:cNvPr id="3" name="Notes Placeholder 2"/>
-          <p:cNvSpPr>
-            <a:spLocks xmlns:a="http://schemas.openxmlformats.org/drawingml/2006/main" noGrp="1"/>
-          </p:cNvSpPr>
-          <p:nvPr>
-            <p:ph type="body" idx="1"/>
-          </p:nvPr>
-        </p:nvSpPr>
-        <p:spPr/>
-        <p:txBody>
-          <a:bodyPr xmlns:a="http://schemas.openxmlformats.org/drawingml/2006/main"/>
-          <a:lstStyle xmlns:a="http://schemas.openxmlformats.org/drawingml/2006/main"/>
-          <a:p xmlns:a="http://schemas.openxmlformats.org/drawingml/2006/main">
-            <a:r>
               <a:t>Native package v1.1.6 merged into main, as confirmed in project conversation. Source: https://github.com/VandanaAjayDubey111/great-pm/blob/main/docs/CODEX.md. Prepared MCP implementation: https://github.com/VandanaAjayDubey111/great-pm/pull/3. No newly completed MCP deployment is part of this submission. The only real user feedback summarized here is creator feedback. Future validation is not completed evidence.</a:t>
-            </a:r>
-          </a:p>
-        </p:txBody>
-      </p:sp>
-      <p:sp>
-        <p:nvSpPr>
-          <p:cNvPr id="4" name="Slide Number Placeholder 3"/>
-          <p:cNvSpPr>
-            <a:spLocks xmlns:a="http://schemas.openxmlformats.org/drawingml/2006/main" noGrp="1"/>
-          </p:cNvSpPr>
-          <p:nvPr>
-            <p:ph type="sldNum" idx="5"/>
-          </p:nvPr>
-        </p:nvSpPr>
-        <p:spPr/>
-        <p:txBody>
-          <a:bodyPr xmlns:a="http://schemas.openxmlformats.org/drawingml/2006/main"/>
-          <a:lstStyle xmlns:a="http://schemas.openxmlformats.org/drawingml/2006/main"/>
-          <a:p xmlns:a="http://schemas.openxmlformats.org/drawingml/2006/main"/>
-        </p:txBody>
-      </p:sp>
-    </p:spTree>
-  </p:cSld>
-  <p:clrMapOvr>
-    <a:masterClrMapping xmlns:a="http://schemas.openxmlformats.org/drawingml/2006/main"/>
-  </p:clrMapOvr>
-</p:notes>
-</file>
-
-<file path=ppt/notesSlides/notesSlide13.xml><?xml version="1.0" encoding="utf-8"?>
-<p:notes xmlns:p="http://schemas.openxmlformats.org/presentationml/2006/main">
-  <p:cSld>
-    <p:spTree>
-      <p:nvGrpSpPr>
-        <p:cNvPr id="1" name=""/>
-        <p:cNvGrpSpPr/>
-        <p:nvPr/>
-      </p:nvGrpSpPr>
-      <p:grpSpPr>
-        <a:xfrm xmlns:a="http://schemas.openxmlformats.org/drawingml/2006/main"/>
-      </p:grpSpPr>
-      <p:sp>
-        <p:nvSpPr>
-          <p:cNvPr id="2" name="Slide Image Placeholder 1"/>
-          <p:cNvSpPr>
-            <a:spLocks xmlns:a="http://schemas.openxmlformats.org/drawingml/2006/main" noGrp="1"/>
-          </p:cNvSpPr>
-          <p:nvPr>
-            <p:ph type="sldImg" idx="0"/>
-          </p:nvPr>
-        </p:nvSpPr>
-        <p:spPr/>
-      </p:sp>
-      <p:sp>
-        <p:nvSpPr>
-          <p:cNvPr id="3" name="Notes Placeholder 2"/>
-          <p:cNvSpPr>
-            <a:spLocks xmlns:a="http://schemas.openxmlformats.org/drawingml/2006/main" noGrp="1"/>
-          </p:cNvSpPr>
-          <p:nvPr>
-            <p:ph type="body" idx="1"/>
-          </p:nvPr>
-        </p:nvSpPr>
-        <p:spPr/>
-        <p:txBody>
-          <a:bodyPr xmlns:a="http://schemas.openxmlformats.org/drawingml/2006/main"/>
-          <a:lstStyle xmlns:a="http://schemas.openxmlformats.org/drawingml/2006/main"/>
-          <a:p xmlns:a="http://schemas.openxmlformats.org/drawingml/2006/main">
-            <a:r>
-              <a:t>Product link: https://github.com/VandanaAjayDubey111/great-pm. Install source: https://github.com/VandanaAjayDubey111/great-pm/blob/main/docs/CODEX.md. Codex installation uses marketplace add then plugin add. Start a new session and invoke $pm-help, $grill-me or $pm-start. Claude Code uses its native plugin marketplace and /pm-start. Read repository prerequisites. Talk track: open the repository, invoke $grill-me for a product idea, then open the local board. No live MCP launch claimed.</a:t>
             </a:r>
           </a:p>
         </p:txBody>
@@ -1362,7 +1149,7 @@
   </p:cSld>
   <p:clrMap bg1="lt1" tx1="dk1" bg2="lt2" tx2="dk2" accent1="accent1" accent2="accent2" accent3="accent3" accent4="accent4" accent5="accent5" accent6="accent6" hlink="hlink" folHlink="folHlink"/>
   <p:sldLayoutIdLst>
-    <p:sldLayoutId xmlns:r="http://schemas.openxmlformats.org/officeDocument/2006/relationships" id="2147483649" r:id="Rdd76b3f1feb8405a"/>
+    <p:sldLayoutId xmlns:r="http://schemas.openxmlformats.org/officeDocument/2006/relationships" id="2147483649" r:id="R863912944f674d9a"/>
   </p:sldLayoutIdLst>
   <p:txStyles>
     <p:titleStyle>
@@ -1913,7 +1700,7 @@
           <p:cNvPr id="6" name="">
             <a:extLst xmlns:a="http://schemas.openxmlformats.org/drawingml/2006/main">
               <a:ext uri="{FF2B5EF4-FFF2-40B4-BE49-F238E27FC236}">
-                <a16:creationId xmlns:a16="http://schemas.microsoft.com/office/drawing/2014/main" id="{9EB7F766-D50E-40F7-A0CD-F2F803B9D2F0}"/>
+                <a16:creationId xmlns:a16="http://schemas.microsoft.com/office/drawing/2014/main" id="{E6C0727F-24D8-4B65-8BEA-333E7C192A11}"/>
               </a:ext>
             </a:extLst>
           </p:cNvPr>
@@ -1970,7 +1757,7 @@
           <p:cNvPr id="2" name="">
             <a:extLst xmlns:a="http://schemas.openxmlformats.org/drawingml/2006/main">
               <a:ext uri="{FF2B5EF4-FFF2-40B4-BE49-F238E27FC236}">
-                <a16:creationId xmlns:a16="http://schemas.microsoft.com/office/drawing/2014/main" id="{4D00E105-7422-45A8-9B83-393BABA21C4B}"/>
+                <a16:creationId xmlns:a16="http://schemas.microsoft.com/office/drawing/2014/main" id="{43476D3F-8422-4905-AD97-3EE3713B3318}"/>
               </a:ext>
             </a:extLst>
           </p:cNvPr>
@@ -2027,7 +1814,7 @@
           <p:cNvPr id="3" name="">
             <a:extLst xmlns:a="http://schemas.openxmlformats.org/drawingml/2006/main">
               <a:ext uri="{FF2B5EF4-FFF2-40B4-BE49-F238E27FC236}">
-                <a16:creationId xmlns:a16="http://schemas.microsoft.com/office/drawing/2014/main" id="{558E6848-2876-4C8F-A8D4-3151B956FAD9}"/>
+                <a16:creationId xmlns:a16="http://schemas.microsoft.com/office/drawing/2014/main" id="{AF8301F8-65BD-4657-B7B9-F5CDE689A3F7}"/>
               </a:ext>
             </a:extLst>
           </p:cNvPr>
@@ -2084,7 +1871,7 @@
           <p:cNvPr id="4" name="">
             <a:extLst xmlns:a="http://schemas.openxmlformats.org/drawingml/2006/main">
               <a:ext uri="{FF2B5EF4-FFF2-40B4-BE49-F238E27FC236}">
-                <a16:creationId xmlns:a16="http://schemas.microsoft.com/office/drawing/2014/main" id="{3D28BBAB-5302-4542-ACB0-012E7B03EB99}"/>
+                <a16:creationId xmlns:a16="http://schemas.microsoft.com/office/drawing/2014/main" id="{0E165E14-F0E4-4A4B-93A1-672A900FD6ED}"/>
               </a:ext>
             </a:extLst>
           </p:cNvPr>
@@ -2164,7 +1951,7 @@
           <p:cNvPr id="5" name="">
             <a:extLst xmlns:a="http://schemas.openxmlformats.org/drawingml/2006/main">
               <a:ext uri="{FF2B5EF4-FFF2-40B4-BE49-F238E27FC236}">
-                <a16:creationId xmlns:a16="http://schemas.microsoft.com/office/drawing/2014/main" id="{40079290-04CD-4205-B609-3A1DF1621530}"/>
+                <a16:creationId xmlns:a16="http://schemas.microsoft.com/office/drawing/2014/main" id="{78DC104C-44F1-43D4-8027-D2320C2D8C86}"/>
               </a:ext>
             </a:extLst>
           </p:cNvPr>
@@ -2242,7 +2029,7 @@
     </p:spTree>
     <p:extLst>
       <p:ext uri="{BB962C8B-B14F-4D97-AF65-F5344CB8AC3E}">
-        <p14:creationId xmlns:p14="http://schemas.microsoft.com/office/powerpoint/2010/main" val="1956181154"/>
+        <p14:creationId xmlns:p14="http://schemas.microsoft.com/office/powerpoint/2010/main" val="787664187"/>
       </p:ext>
     </p:extLst>
   </p:cSld>
@@ -2250,605 +2037,6 @@
 </file>
 
 <file path=ppt/slides/slide10.xml><?xml version="1.0" encoding="utf-8"?>
-<p:sld xmlns:p="http://schemas.openxmlformats.org/presentationml/2006/main">
-  <p:cSld>
-    <p:bg>
-      <p:bgPr>
-        <a:solidFill xmlns:a="http://schemas.openxmlformats.org/drawingml/2006/main">
-          <a:srgbClr val="173F35"/>
-        </a:solidFill>
-      </p:bgPr>
-    </p:bg>
-    <p:spTree>
-      <p:nvGrpSpPr>
-        <p:cNvPr id="1" name=""/>
-        <p:cNvGrpSpPr/>
-        <p:nvPr/>
-      </p:nvGrpSpPr>
-      <p:grpSpPr>
-        <a:xfrm xmlns:a="http://schemas.openxmlformats.org/drawingml/2006/main"/>
-      </p:grpSpPr>
-      <p:sp>
-        <p:nvSpPr>
-          <p:cNvPr id="11" name="">
-            <a:extLst xmlns:a="http://schemas.openxmlformats.org/drawingml/2006/main">
-              <a:ext uri="{FF2B5EF4-FFF2-40B4-BE49-F238E27FC236}">
-                <a16:creationId xmlns:a16="http://schemas.microsoft.com/office/drawing/2014/main" id="{37AE1E50-CB16-4677-B942-80AB92D90336}"/>
-              </a:ext>
-            </a:extLst>
-          </p:cNvPr>
-          <p:cNvSpPr>
-            <a:spLocks xmlns:a="http://schemas.openxmlformats.org/drawingml/2006/main" noGrp="1"/>
-          </p:cNvSpPr>
-          <p:nvPr/>
-        </p:nvSpPr>
-        <p:spPr>
-          <a:xfrm xmlns:a="http://schemas.openxmlformats.org/drawingml/2006/main">
-            <a:off x="609600" y="476250"/>
-            <a:ext cx="10953750" cy="914400"/>
-          </a:xfrm>
-          <a:prstGeom xmlns:a="http://schemas.openxmlformats.org/drawingml/2006/main" prst="rect">
-            <a:avLst/>
-          </a:prstGeom>
-          <a:noFill xmlns:a="http://schemas.openxmlformats.org/drawingml/2006/main"/>
-          <a:ln xmlns:a="http://schemas.openxmlformats.org/drawingml/2006/main" w="0">
-            <a:noFill/>
-          </a:ln>
-        </p:spPr>
-        <p:txBody>
-          <a:bodyPr xmlns:a="http://schemas.openxmlformats.org/drawingml/2006/main">
-            <a:noAutofit/>
-          </a:bodyPr>
-          <a:lstStyle xmlns:a="http://schemas.openxmlformats.org/drawingml/2006/main"/>
-          <a:p xmlns:a="http://schemas.openxmlformats.org/drawingml/2006/main">
-            <a:pPr>
-              <a:defRPr sz="3450" b="1">
-                <a:solidFill>
-                  <a:srgbClr val="F4F1E7"/>
-                </a:solidFill>
-                <a:latin typeface="Helvetica Neue"/>
-                <a:ea typeface="Helvetica Neue"/>
-                <a:cs typeface="Helvetica Neue"/>
-              </a:defRPr>
-            </a:pPr>
-            <a:r>
-              <a:rPr sz="3450" b="1">
-                <a:solidFill>
-                  <a:srgbClr val="F4F1E7"/>
-                </a:solidFill>
-                <a:latin typeface="Helvetica Neue"/>
-                <a:ea typeface="Helvetica Neue"/>
-                <a:cs typeface="Helvetica Neue"/>
-              </a:rPr>
-              <a:t>Data boundaries and operating limits</a:t>
-            </a:r>
-          </a:p>
-        </p:txBody>
-      </p:sp>
-      <p:sp>
-        <p:nvSpPr>
-          <p:cNvPr id="2" name="">
-            <a:extLst xmlns:a="http://schemas.openxmlformats.org/drawingml/2006/main">
-              <a:ext uri="{FF2B5EF4-FFF2-40B4-BE49-F238E27FC236}">
-                <a16:creationId xmlns:a16="http://schemas.microsoft.com/office/drawing/2014/main" id="{80E9A927-F5A1-4F3A-8BCE-C060B45AD59E}"/>
-              </a:ext>
-            </a:extLst>
-          </p:cNvPr>
-          <p:cNvSpPr>
-            <a:spLocks xmlns:a="http://schemas.openxmlformats.org/drawingml/2006/main" noGrp="1"/>
-          </p:cNvSpPr>
-          <p:nvPr/>
-        </p:nvSpPr>
-        <p:spPr>
-          <a:xfrm xmlns:a="http://schemas.openxmlformats.org/drawingml/2006/main">
-            <a:off x="11144250" y="6315075"/>
-            <a:ext cx="457200" cy="257175"/>
-          </a:xfrm>
-          <a:prstGeom xmlns:a="http://schemas.openxmlformats.org/drawingml/2006/main" prst="rect">
-            <a:avLst/>
-          </a:prstGeom>
-          <a:noFill xmlns:a="http://schemas.openxmlformats.org/drawingml/2006/main"/>
-          <a:ln xmlns:a="http://schemas.openxmlformats.org/drawingml/2006/main" w="0">
-            <a:noFill/>
-          </a:ln>
-        </p:spPr>
-        <p:txBody>
-          <a:bodyPr xmlns:a="http://schemas.openxmlformats.org/drawingml/2006/main">
-            <a:noAutofit/>
-          </a:bodyPr>
-          <a:lstStyle xmlns:a="http://schemas.openxmlformats.org/drawingml/2006/main"/>
-          <a:p xmlns:a="http://schemas.openxmlformats.org/drawingml/2006/main">
-            <a:pPr>
-              <a:defRPr sz="1350" b="0">
-                <a:solidFill>
-                  <a:srgbClr val="D8E5DA"/>
-                </a:solidFill>
-                <a:latin typeface="Helvetica Neue"/>
-                <a:ea typeface="Helvetica Neue"/>
-                <a:cs typeface="Helvetica Neue"/>
-              </a:defRPr>
-            </a:pPr>
-            <a:r>
-              <a:rPr sz="1350" b="0">
-                <a:solidFill>
-                  <a:srgbClr val="D8E5DA"/>
-                </a:solidFill>
-                <a:latin typeface="Helvetica Neue"/>
-                <a:ea typeface="Helvetica Neue"/>
-                <a:cs typeface="Helvetica Neue"/>
-              </a:rPr>
-              <a:t>10</a:t>
-            </a:r>
-          </a:p>
-        </p:txBody>
-      </p:sp>
-      <p:sp>
-        <p:nvSpPr>
-          <p:cNvPr id="3" name="">
-            <a:extLst xmlns:a="http://schemas.openxmlformats.org/drawingml/2006/main">
-              <a:ext uri="{FF2B5EF4-FFF2-40B4-BE49-F238E27FC236}">
-                <a16:creationId xmlns:a16="http://schemas.microsoft.com/office/drawing/2014/main" id="{ABE70E8B-65C5-4C46-8470-8DEC790A260F}"/>
-              </a:ext>
-            </a:extLst>
-          </p:cNvPr>
-          <p:cNvSpPr>
-            <a:spLocks xmlns:a="http://schemas.openxmlformats.org/drawingml/2006/main" noGrp="1"/>
-          </p:cNvSpPr>
-          <p:nvPr/>
-        </p:nvSpPr>
-        <p:spPr>
-          <a:xfrm xmlns:a="http://schemas.openxmlformats.org/drawingml/2006/main">
-            <a:off x="619125" y="1628775"/>
-            <a:ext cx="5029200" cy="457200"/>
-          </a:xfrm>
-          <a:prstGeom xmlns:a="http://schemas.openxmlformats.org/drawingml/2006/main" prst="rect">
-            <a:avLst/>
-          </a:prstGeom>
-          <a:noFill xmlns:a="http://schemas.openxmlformats.org/drawingml/2006/main"/>
-          <a:ln xmlns:a="http://schemas.openxmlformats.org/drawingml/2006/main" w="0">
-            <a:noFill/>
-          </a:ln>
-        </p:spPr>
-        <p:txBody>
-          <a:bodyPr xmlns:a="http://schemas.openxmlformats.org/drawingml/2006/main">
-            <a:noAutofit/>
-          </a:bodyPr>
-          <a:lstStyle xmlns:a="http://schemas.openxmlformats.org/drawingml/2006/main"/>
-          <a:p xmlns:a="http://schemas.openxmlformats.org/drawingml/2006/main">
-            <a:pPr>
-              <a:defRPr sz="2175" b="1">
-                <a:solidFill>
-                  <a:srgbClr val="F4F1E7"/>
-                </a:solidFill>
-                <a:latin typeface="Helvetica Neue"/>
-                <a:ea typeface="Helvetica Neue"/>
-                <a:cs typeface="Helvetica Neue"/>
-              </a:defRPr>
-            </a:pPr>
-            <a:r>
-              <a:rPr sz="2175" b="1">
-                <a:solidFill>
-                  <a:srgbClr val="F4F1E7"/>
-                </a:solidFill>
-                <a:latin typeface="Helvetica Neue"/>
-                <a:ea typeface="Helvetica Neue"/>
-                <a:cs typeface="Helvetica Neue"/>
-              </a:rPr>
-              <a:t>Native experience</a:t>
-            </a:r>
-          </a:p>
-        </p:txBody>
-      </p:sp>
-      <p:sp>
-        <p:nvSpPr>
-          <p:cNvPr id="4" name="">
-            <a:extLst xmlns:a="http://schemas.openxmlformats.org/drawingml/2006/main">
-              <a:ext uri="{FF2B5EF4-FFF2-40B4-BE49-F238E27FC236}">
-                <a16:creationId xmlns:a16="http://schemas.microsoft.com/office/drawing/2014/main" id="{A6B4692C-85BC-4D69-8005-21C317A05E2B}"/>
-              </a:ext>
-            </a:extLst>
-          </p:cNvPr>
-          <p:cNvSpPr>
-            <a:spLocks xmlns:a="http://schemas.openxmlformats.org/drawingml/2006/main" noGrp="1"/>
-          </p:cNvSpPr>
-          <p:nvPr/>
-        </p:nvSpPr>
-        <p:spPr>
-          <a:xfrm xmlns:a="http://schemas.openxmlformats.org/drawingml/2006/main">
-            <a:off x="619125" y="2181225"/>
-            <a:ext cx="5029200" cy="1619250"/>
-          </a:xfrm>
-          <a:prstGeom xmlns:a="http://schemas.openxmlformats.org/drawingml/2006/main" prst="rect">
-            <a:avLst/>
-          </a:prstGeom>
-          <a:noFill xmlns:a="http://schemas.openxmlformats.org/drawingml/2006/main"/>
-          <a:ln xmlns:a="http://schemas.openxmlformats.org/drawingml/2006/main" w="0">
-            <a:noFill/>
-          </a:ln>
-        </p:spPr>
-        <p:txBody>
-          <a:bodyPr xmlns:a="http://schemas.openxmlformats.org/drawingml/2006/main">
-            <a:noAutofit/>
-          </a:bodyPr>
-          <a:lstStyle xmlns:a="http://schemas.openxmlformats.org/drawingml/2006/main"/>
-          <a:p xmlns:a="http://schemas.openxmlformats.org/drawingml/2006/main">
-            <a:pPr>
-              <a:defRPr sz="2025" b="0">
-                <a:solidFill>
-                  <a:srgbClr val="D8E5DA"/>
-                </a:solidFill>
-                <a:latin typeface="Helvetica Neue"/>
-                <a:ea typeface="Helvetica Neue"/>
-                <a:cs typeface="Helvetica Neue"/>
-              </a:defRPr>
-            </a:pPr>
-            <a:r>
-              <a:rPr sz="2025" b="0">
-                <a:solidFill>
-                  <a:srgbClr val="D8E5DA"/>
-                </a:solidFill>
-                <a:latin typeface="Helvetica Neue"/>
-                <a:ea typeface="Helvetica Neue"/>
-                <a:cs typeface="Helvetica Neue"/>
-              </a:rPr>
-              <a:t>The host works with local .great-pm files. Optional connectors require configuration and governance.</a:t>
-            </a:r>
-          </a:p>
-        </p:txBody>
-      </p:sp>
-      <p:sp>
-        <p:nvSpPr>
-          <p:cNvPr id="5" name="">
-            <a:extLst xmlns:a="http://schemas.openxmlformats.org/drawingml/2006/main">
-              <a:ext uri="{FF2B5EF4-FFF2-40B4-BE49-F238E27FC236}">
-                <a16:creationId xmlns:a16="http://schemas.microsoft.com/office/drawing/2014/main" id="{A8E14CD8-BC95-480A-8C6C-D2F8BB444CD8}"/>
-              </a:ext>
-            </a:extLst>
-          </p:cNvPr>
-          <p:cNvSpPr>
-            <a:spLocks xmlns:a="http://schemas.openxmlformats.org/drawingml/2006/main" noGrp="1"/>
-          </p:cNvSpPr>
-          <p:nvPr/>
-        </p:nvSpPr>
-        <p:spPr>
-          <a:xfrm xmlns:a="http://schemas.openxmlformats.org/drawingml/2006/main">
-            <a:off x="6238875" y="1628775"/>
-            <a:ext cx="5286375" cy="457200"/>
-          </a:xfrm>
-          <a:prstGeom xmlns:a="http://schemas.openxmlformats.org/drawingml/2006/main" prst="rect">
-            <a:avLst/>
-          </a:prstGeom>
-          <a:noFill xmlns:a="http://schemas.openxmlformats.org/drawingml/2006/main"/>
-          <a:ln xmlns:a="http://schemas.openxmlformats.org/drawingml/2006/main" w="0">
-            <a:noFill/>
-          </a:ln>
-        </p:spPr>
-        <p:txBody>
-          <a:bodyPr xmlns:a="http://schemas.openxmlformats.org/drawingml/2006/main">
-            <a:noAutofit/>
-          </a:bodyPr>
-          <a:lstStyle xmlns:a="http://schemas.openxmlformats.org/drawingml/2006/main"/>
-          <a:p xmlns:a="http://schemas.openxmlformats.org/drawingml/2006/main">
-            <a:pPr>
-              <a:defRPr sz="2175" b="1">
-                <a:solidFill>
-                  <a:srgbClr val="F4F1E7"/>
-                </a:solidFill>
-                <a:latin typeface="Helvetica Neue"/>
-                <a:ea typeface="Helvetica Neue"/>
-                <a:cs typeface="Helvetica Neue"/>
-              </a:defRPr>
-            </a:pPr>
-            <a:r>
-              <a:rPr sz="2175" b="1">
-                <a:solidFill>
-                  <a:srgbClr val="F4F1E7"/>
-                </a:solidFill>
-                <a:latin typeface="Helvetica Neue"/>
-                <a:ea typeface="Helvetica Neue"/>
-                <a:cs typeface="Helvetica Neue"/>
-              </a:rPr>
-              <a:t>Public MCP boundary</a:t>
-            </a:r>
-          </a:p>
-        </p:txBody>
-      </p:sp>
-      <p:sp>
-        <p:nvSpPr>
-          <p:cNvPr id="6" name="">
-            <a:extLst xmlns:a="http://schemas.openxmlformats.org/drawingml/2006/main">
-              <a:ext uri="{FF2B5EF4-FFF2-40B4-BE49-F238E27FC236}">
-                <a16:creationId xmlns:a16="http://schemas.microsoft.com/office/drawing/2014/main" id="{88BB7528-0D40-406A-B9AF-BCA31FF50FB7}"/>
-              </a:ext>
-            </a:extLst>
-          </p:cNvPr>
-          <p:cNvSpPr>
-            <a:spLocks xmlns:a="http://schemas.openxmlformats.org/drawingml/2006/main" noGrp="1"/>
-          </p:cNvSpPr>
-          <p:nvPr/>
-        </p:nvSpPr>
-        <p:spPr>
-          <a:xfrm xmlns:a="http://schemas.openxmlformats.org/drawingml/2006/main">
-            <a:off x="6238875" y="2181225"/>
-            <a:ext cx="5286375" cy="1619250"/>
-          </a:xfrm>
-          <a:prstGeom xmlns:a="http://schemas.openxmlformats.org/drawingml/2006/main" prst="rect">
-            <a:avLst/>
-          </a:prstGeom>
-          <a:noFill xmlns:a="http://schemas.openxmlformats.org/drawingml/2006/main"/>
-          <a:ln xmlns:a="http://schemas.openxmlformats.org/drawingml/2006/main" w="0">
-            <a:noFill/>
-          </a:ln>
-        </p:spPr>
-        <p:txBody>
-          <a:bodyPr xmlns:a="http://schemas.openxmlformats.org/drawingml/2006/main">
-            <a:noAutofit/>
-          </a:bodyPr>
-          <a:lstStyle xmlns:a="http://schemas.openxmlformats.org/drawingml/2006/main"/>
-          <a:p xmlns:a="http://schemas.openxmlformats.org/drawingml/2006/main">
-            <a:pPr>
-              <a:defRPr sz="2025" b="0">
-                <a:solidFill>
-                  <a:srgbClr val="D8E5DA"/>
-                </a:solidFill>
-                <a:latin typeface="Helvetica Neue"/>
-                <a:ea typeface="Helvetica Neue"/>
-                <a:cs typeface="Helvetica Neue"/>
-              </a:defRPr>
-            </a:pPr>
-            <a:r>
-              <a:rPr sz="2025" b="0">
-                <a:solidFill>
-                  <a:srgbClr val="D8E5DA"/>
-                </a:solidFill>
-                <a:latin typeface="Helvetica Neue"/>
-                <a:ea typeface="Helvetica Neue"/>
-                <a:cs typeface="Helvetica Neue"/>
-              </a:rPr>
-              <a:t>Static knowledge only. No project access, model calls or external writes.</a:t>
-            </a:r>
-          </a:p>
-        </p:txBody>
-      </p:sp>
-      <p:sp>
-        <p:nvSpPr>
-          <p:cNvPr id="7" name="">
-            <a:extLst xmlns:a="http://schemas.openxmlformats.org/drawingml/2006/main">
-              <a:ext uri="{FF2B5EF4-FFF2-40B4-BE49-F238E27FC236}">
-                <a16:creationId xmlns:a16="http://schemas.microsoft.com/office/drawing/2014/main" id="{8EE4E115-2B54-4400-9808-E31297060330}"/>
-              </a:ext>
-            </a:extLst>
-          </p:cNvPr>
-          <p:cNvSpPr>
-            <a:spLocks xmlns:a="http://schemas.openxmlformats.org/drawingml/2006/main" noGrp="1"/>
-          </p:cNvSpPr>
-          <p:nvPr/>
-        </p:nvSpPr>
-        <p:spPr>
-          <a:xfrm xmlns:a="http://schemas.openxmlformats.org/drawingml/2006/main">
-            <a:off x="619125" y="3914775"/>
-            <a:ext cx="5029200" cy="457200"/>
-          </a:xfrm>
-          <a:prstGeom xmlns:a="http://schemas.openxmlformats.org/drawingml/2006/main" prst="rect">
-            <a:avLst/>
-          </a:prstGeom>
-          <a:noFill xmlns:a="http://schemas.openxmlformats.org/drawingml/2006/main"/>
-          <a:ln xmlns:a="http://schemas.openxmlformats.org/drawingml/2006/main" w="0">
-            <a:noFill/>
-          </a:ln>
-        </p:spPr>
-        <p:txBody>
-          <a:bodyPr xmlns:a="http://schemas.openxmlformats.org/drawingml/2006/main">
-            <a:noAutofit/>
-          </a:bodyPr>
-          <a:lstStyle xmlns:a="http://schemas.openxmlformats.org/drawingml/2006/main"/>
-          <a:p xmlns:a="http://schemas.openxmlformats.org/drawingml/2006/main">
-            <a:pPr>
-              <a:defRPr sz="2175" b="1">
-                <a:solidFill>
-                  <a:srgbClr val="F4F1E7"/>
-                </a:solidFill>
-                <a:latin typeface="Helvetica Neue"/>
-                <a:ea typeface="Helvetica Neue"/>
-                <a:cs typeface="Helvetica Neue"/>
-              </a:defRPr>
-            </a:pPr>
-            <a:r>
-              <a:rPr sz="2175" b="1">
-                <a:solidFill>
-                  <a:srgbClr val="F4F1E7"/>
-                </a:solidFill>
-                <a:latin typeface="Helvetica Neue"/>
-                <a:ea typeface="Helvetica Neue"/>
-                <a:cs typeface="Helvetica Neue"/>
-              </a:rPr>
-              <a:t>Data care</a:t>
-            </a:r>
-          </a:p>
-        </p:txBody>
-      </p:sp>
-      <p:sp>
-        <p:nvSpPr>
-          <p:cNvPr id="8" name="">
-            <a:extLst xmlns:a="http://schemas.openxmlformats.org/drawingml/2006/main">
-              <a:ext uri="{FF2B5EF4-FFF2-40B4-BE49-F238E27FC236}">
-                <a16:creationId xmlns:a16="http://schemas.microsoft.com/office/drawing/2014/main" id="{9199A182-9601-453F-8DF5-B861F0BC056A}"/>
-              </a:ext>
-            </a:extLst>
-          </p:cNvPr>
-          <p:cNvSpPr>
-            <a:spLocks xmlns:a="http://schemas.openxmlformats.org/drawingml/2006/main" noGrp="1"/>
-          </p:cNvSpPr>
-          <p:nvPr/>
-        </p:nvSpPr>
-        <p:spPr>
-          <a:xfrm xmlns:a="http://schemas.openxmlformats.org/drawingml/2006/main">
-            <a:off x="619125" y="4467225"/>
-            <a:ext cx="5029200" cy="1619250"/>
-          </a:xfrm>
-          <a:prstGeom xmlns:a="http://schemas.openxmlformats.org/drawingml/2006/main" prst="rect">
-            <a:avLst/>
-          </a:prstGeom>
-          <a:noFill xmlns:a="http://schemas.openxmlformats.org/drawingml/2006/main"/>
-          <a:ln xmlns:a="http://schemas.openxmlformats.org/drawingml/2006/main" w="0">
-            <a:noFill/>
-          </a:ln>
-        </p:spPr>
-        <p:txBody>
-          <a:bodyPr xmlns:a="http://schemas.openxmlformats.org/drawingml/2006/main">
-            <a:noAutofit/>
-          </a:bodyPr>
-          <a:lstStyle xmlns:a="http://schemas.openxmlformats.org/drawingml/2006/main"/>
-          <a:p xmlns:a="http://schemas.openxmlformats.org/drawingml/2006/main">
-            <a:pPr>
-              <a:defRPr sz="2025" b="0">
-                <a:solidFill>
-                  <a:srgbClr val="D8E5DA"/>
-                </a:solidFill>
-                <a:latin typeface="Helvetica Neue"/>
-                <a:ea typeface="Helvetica Neue"/>
-                <a:cs typeface="Helvetica Neue"/>
-              </a:defRPr>
-            </a:pPr>
-            <a:r>
-              <a:rPr sz="2025" b="0">
-                <a:solidFill>
-                  <a:srgbClr val="D8E5DA"/>
-                </a:solidFill>
-                <a:latin typeface="Helvetica Neue"/>
-                <a:ea typeface="Helvetica Neue"/>
-                <a:cs typeface="Helvetica Neue"/>
-              </a:rPr>
-              <a:t>Host and model-provider policies still apply. Public MCP arguments should contain no confidential or personal data.</a:t>
-            </a:r>
-          </a:p>
-        </p:txBody>
-      </p:sp>
-      <p:sp>
-        <p:nvSpPr>
-          <p:cNvPr id="9" name="">
-            <a:extLst xmlns:a="http://schemas.openxmlformats.org/drawingml/2006/main">
-              <a:ext uri="{FF2B5EF4-FFF2-40B4-BE49-F238E27FC236}">
-                <a16:creationId xmlns:a16="http://schemas.microsoft.com/office/drawing/2014/main" id="{C629D68A-0CF3-4259-B58F-65BB3F537D75}"/>
-              </a:ext>
-            </a:extLst>
-          </p:cNvPr>
-          <p:cNvSpPr>
-            <a:spLocks xmlns:a="http://schemas.openxmlformats.org/drawingml/2006/main" noGrp="1"/>
-          </p:cNvSpPr>
-          <p:nvPr/>
-        </p:nvSpPr>
-        <p:spPr>
-          <a:xfrm xmlns:a="http://schemas.openxmlformats.org/drawingml/2006/main">
-            <a:off x="6238875" y="3914775"/>
-            <a:ext cx="5286375" cy="457200"/>
-          </a:xfrm>
-          <a:prstGeom xmlns:a="http://schemas.openxmlformats.org/drawingml/2006/main" prst="rect">
-            <a:avLst/>
-          </a:prstGeom>
-          <a:noFill xmlns:a="http://schemas.openxmlformats.org/drawingml/2006/main"/>
-          <a:ln xmlns:a="http://schemas.openxmlformats.org/drawingml/2006/main" w="0">
-            <a:noFill/>
-          </a:ln>
-        </p:spPr>
-        <p:txBody>
-          <a:bodyPr xmlns:a="http://schemas.openxmlformats.org/drawingml/2006/main">
-            <a:noAutofit/>
-          </a:bodyPr>
-          <a:lstStyle xmlns:a="http://schemas.openxmlformats.org/drawingml/2006/main"/>
-          <a:p xmlns:a="http://schemas.openxmlformats.org/drawingml/2006/main">
-            <a:pPr>
-              <a:defRPr sz="2175" b="1">
-                <a:solidFill>
-                  <a:srgbClr val="F4F1E7"/>
-                </a:solidFill>
-                <a:latin typeface="Helvetica Neue"/>
-                <a:ea typeface="Helvetica Neue"/>
-                <a:cs typeface="Helvetica Neue"/>
-              </a:defRPr>
-            </a:pPr>
-            <a:r>
-              <a:rPr sz="2175" b="1">
-                <a:solidFill>
-                  <a:srgbClr val="F4F1E7"/>
-                </a:solidFill>
-                <a:latin typeface="Helvetica Neue"/>
-                <a:ea typeface="Helvetica Neue"/>
-                <a:cs typeface="Helvetica Neue"/>
-              </a:rPr>
-              <a:t>Cost and ownership</a:t>
-            </a:r>
-          </a:p>
-        </p:txBody>
-      </p:sp>
-      <p:sp>
-        <p:nvSpPr>
-          <p:cNvPr id="10" name="">
-            <a:extLst xmlns:a="http://schemas.openxmlformats.org/drawingml/2006/main">
-              <a:ext uri="{FF2B5EF4-FFF2-40B4-BE49-F238E27FC236}">
-                <a16:creationId xmlns:a16="http://schemas.microsoft.com/office/drawing/2014/main" id="{07C68A6C-A187-4BA3-9208-71DC156E5222}"/>
-              </a:ext>
-            </a:extLst>
-          </p:cNvPr>
-          <p:cNvSpPr>
-            <a:spLocks xmlns:a="http://schemas.openxmlformats.org/drawingml/2006/main" noGrp="1"/>
-          </p:cNvSpPr>
-          <p:nvPr/>
-        </p:nvSpPr>
-        <p:spPr>
-          <a:xfrm xmlns:a="http://schemas.openxmlformats.org/drawingml/2006/main">
-            <a:off x="6238875" y="4467225"/>
-            <a:ext cx="5286375" cy="1619250"/>
-          </a:xfrm>
-          <a:prstGeom xmlns:a="http://schemas.openxmlformats.org/drawingml/2006/main" prst="rect">
-            <a:avLst/>
-          </a:prstGeom>
-          <a:noFill xmlns:a="http://schemas.openxmlformats.org/drawingml/2006/main"/>
-          <a:ln xmlns:a="http://schemas.openxmlformats.org/drawingml/2006/main" w="0">
-            <a:noFill/>
-          </a:ln>
-        </p:spPr>
-        <p:txBody>
-          <a:bodyPr xmlns:a="http://schemas.openxmlformats.org/drawingml/2006/main">
-            <a:noAutofit/>
-          </a:bodyPr>
-          <a:lstStyle xmlns:a="http://schemas.openxmlformats.org/drawingml/2006/main"/>
-          <a:p xmlns:a="http://schemas.openxmlformats.org/drawingml/2006/main">
-            <a:pPr>
-              <a:defRPr sz="2025" b="0">
-                <a:solidFill>
-                  <a:srgbClr val="D8E5DA"/>
-                </a:solidFill>
-                <a:latin typeface="Helvetica Neue"/>
-                <a:ea typeface="Helvetica Neue"/>
-                <a:cs typeface="Helvetica Neue"/>
-              </a:defRPr>
-            </a:pPr>
-            <a:r>
-              <a:rPr sz="2025" b="0">
-                <a:solidFill>
-                  <a:srgbClr val="D8E5DA"/>
-                </a:solidFill>
-                <a:latin typeface="Helvetica Neue"/>
-                <a:ea typeface="Helvetica Neue"/>
-                <a:cs typeface="Helvetica Neue"/>
-              </a:rPr>
-              <a:t>MIT-licensed code. Model use, connected tools and hosting may have separate costs.</a:t>
-            </a:r>
-          </a:p>
-        </p:txBody>
-      </p:sp>
-    </p:spTree>
-    <p:extLst>
-      <p:ext uri="{BB962C8B-B14F-4D97-AF65-F5344CB8AC3E}">
-        <p14:creationId xmlns:p14="http://schemas.microsoft.com/office/powerpoint/2010/main" val="307680907"/>
-      </p:ext>
-    </p:extLst>
-  </p:cSld>
-</p:sld>
-</file>
-
-<file path=ppt/slides/slide11.xml><?xml version="1.0" encoding="utf-8"?>
 <p:sld xmlns:p="http://schemas.openxmlformats.org/presentationml/2006/main">
   <p:cSld>
     <p:bg>
@@ -2869,10 +2057,10 @@
       </p:grpSpPr>
       <p:sp>
         <p:nvSpPr>
-          <p:cNvPr id="6" name="">
+          <p:cNvPr id="9" name="">
             <a:extLst xmlns:a="http://schemas.openxmlformats.org/drawingml/2006/main">
               <a:ext uri="{FF2B5EF4-FFF2-40B4-BE49-F238E27FC236}">
-                <a16:creationId xmlns:a16="http://schemas.microsoft.com/office/drawing/2014/main" id="{C964459E-06E3-49F3-87C0-438F3045C506}"/>
+                <a16:creationId xmlns:a16="http://schemas.microsoft.com/office/drawing/2014/main" id="{14052C27-A29E-4301-9F2B-E79D50248827}"/>
               </a:ext>
             </a:extLst>
           </p:cNvPr>
@@ -2919,7 +2107,7 @@
                 <a:ea typeface="Helvetica Neue"/>
                 <a:cs typeface="Helvetica Neue"/>
               </a:rPr>
-              <a:t>Creator feedback and product changes</a:t>
+              <a:t>Current status and learning priorities</a:t>
             </a:r>
           </a:p>
         </p:txBody>
@@ -2929,7 +2117,7 @@
           <p:cNvPr id="2" name="">
             <a:extLst xmlns:a="http://schemas.openxmlformats.org/drawingml/2006/main">
               <a:ext uri="{FF2B5EF4-FFF2-40B4-BE49-F238E27FC236}">
-                <a16:creationId xmlns:a16="http://schemas.microsoft.com/office/drawing/2014/main" id="{76F4793D-D0FE-46FC-A2BF-6842D0F86909}"/>
+                <a16:creationId xmlns:a16="http://schemas.microsoft.com/office/drawing/2014/main" id="{CF769DF6-A292-4C6D-8B84-512DA516F15D}"/>
               </a:ext>
             </a:extLst>
           </p:cNvPr>
@@ -2976,7 +2164,7 @@
                 <a:ea typeface="Helvetica Neue"/>
                 <a:cs typeface="Helvetica Neue"/>
               </a:rPr>
-              <a:t>11</a:t>
+              <a:t>10</a:t>
             </a:r>
           </a:p>
         </p:txBody>
@@ -2986,525 +2174,7 @@
           <p:cNvPr id="3" name="">
             <a:extLst xmlns:a="http://schemas.openxmlformats.org/drawingml/2006/main">
               <a:ext uri="{FF2B5EF4-FFF2-40B4-BE49-F238E27FC236}">
-                <a16:creationId xmlns:a16="http://schemas.microsoft.com/office/drawing/2014/main" id="{3A299616-2556-4056-AC43-71FD9EC9E704}"/>
-              </a:ext>
-            </a:extLst>
-          </p:cNvPr>
-          <p:cNvSpPr>
-            <a:spLocks xmlns:a="http://schemas.openxmlformats.org/drawingml/2006/main" noGrp="1"/>
-          </p:cNvSpPr>
-          <p:nvPr/>
-        </p:nvSpPr>
-        <p:spPr>
-          <a:xfrm xmlns:a="http://schemas.openxmlformats.org/drawingml/2006/main">
-            <a:off x="619125" y="1476375"/>
-            <a:ext cx="10668000" cy="409575"/>
-          </a:xfrm>
-          <a:prstGeom xmlns:a="http://schemas.openxmlformats.org/drawingml/2006/main" prst="rect">
-            <a:avLst/>
-          </a:prstGeom>
-          <a:noFill xmlns:a="http://schemas.openxmlformats.org/drawingml/2006/main"/>
-          <a:ln xmlns:a="http://schemas.openxmlformats.org/drawingml/2006/main" w="0">
-            <a:noFill/>
-          </a:ln>
-        </p:spPr>
-        <p:txBody>
-          <a:bodyPr xmlns:a="http://schemas.openxmlformats.org/drawingml/2006/main">
-            <a:noAutofit/>
-          </a:bodyPr>
-          <a:lstStyle xmlns:a="http://schemas.openxmlformats.org/drawingml/2006/main"/>
-          <a:p xmlns:a="http://schemas.openxmlformats.org/drawingml/2006/main">
-            <a:pPr>
-              <a:defRPr sz="2100" b="1">
-                <a:solidFill>
-                  <a:srgbClr val="66756B"/>
-                </a:solidFill>
-                <a:latin typeface="Helvetica Neue"/>
-                <a:ea typeface="Helvetica Neue"/>
-                <a:cs typeface="Helvetica Neue"/>
-              </a:defRPr>
-            </a:pPr>
-            <a:r>
-              <a:rPr sz="2100" b="1">
-                <a:solidFill>
-                  <a:srgbClr val="66756B"/>
-                </a:solidFill>
-                <a:latin typeface="Helvetica Neue"/>
-                <a:ea typeface="Helvetica Neue"/>
-                <a:cs typeface="Helvetica Neue"/>
-              </a:rPr>
-              <a:t>Real creator/user feedback, n = 1</a:t>
-            </a:r>
-          </a:p>
-        </p:txBody>
-      </p:sp>
-      <p:graphicFrame>
-        <p:nvGraphicFramePr>
-          <p:cNvPr id="9" name=""/>
-          <p:cNvGraphicFramePr/>
-          <p:nvPr/>
-        </p:nvGraphicFramePr>
-        <p:xfrm>
-          <a:off xmlns:a="http://schemas.openxmlformats.org/drawingml/2006/main" x="609600" y="2209800"/>
-          <a:ext xmlns:a="http://schemas.openxmlformats.org/drawingml/2006/main" cx="10972800" cy="3028950"/>
-        </p:xfrm>
-        <a:graphic xmlns:a="http://schemas.openxmlformats.org/drawingml/2006/main">
-          <a:graphicData uri="http://schemas.openxmlformats.org/drawingml/2006/table">
-            <a:tbl>
-              <a:tblPr/>
-              <a:tblGrid>
-                <a:gridCol w="5334000"/>
-                <a:gridCol w="5638800"/>
-              </a:tblGrid>
-              <a:tr h="757238">
-                <a:tc>
-                  <a:txBody>
-                    <a:bodyPr>
-                      <a:noAutofit/>
-                    </a:bodyPr>
-                    <a:lstStyle/>
-                    <a:p>
-                      <a:r>
-                        <a:rPr sz="1875" b="1">
-                          <a:solidFill>
-                            <a:srgbClr val="F4F1E7"/>
-                          </a:solidFill>
-                          <a:latin typeface="Helvetica Neue"/>
-                          <a:ea typeface="Helvetica Neue"/>
-                          <a:cs typeface="Helvetica Neue"/>
-                        </a:rPr>
-                        <a:t>Observed issue</a:t>
-                      </a:r>
-                    </a:p>
-                  </a:txBody>
-                  <a:tcPr marL="152400" marR="152400" marT="114300" marB="95250" anchor="ctr">
-                    <a:solidFill>
-                      <a:srgbClr val="173F35"/>
-                    </a:solidFill>
-                  </a:tcPr>
-                </a:tc>
-                <a:tc>
-                  <a:txBody>
-                    <a:bodyPr>
-                      <a:noAutofit/>
-                    </a:bodyPr>
-                    <a:lstStyle/>
-                    <a:p>
-                      <a:r>
-                        <a:rPr sz="1875" b="1">
-                          <a:solidFill>
-                            <a:srgbClr val="F4F1E7"/>
-                          </a:solidFill>
-                          <a:latin typeface="Helvetica Neue"/>
-                          <a:ea typeface="Helvetica Neue"/>
-                          <a:cs typeface="Helvetica Neue"/>
-                        </a:rPr>
-                        <a:t>Product response</a:t>
-                      </a:r>
-                    </a:p>
-                  </a:txBody>
-                  <a:tcPr marL="152400" marR="152400" marT="114300" marB="95250" anchor="ctr">
-                    <a:solidFill>
-                      <a:srgbClr val="173F35"/>
-                    </a:solidFill>
-                  </a:tcPr>
-                </a:tc>
-              </a:tr>
-              <a:tr h="757238">
-                <a:tc>
-                  <a:txBody>
-                    <a:bodyPr>
-                      <a:noAutofit/>
-                    </a:bodyPr>
-                    <a:lstStyle/>
-                    <a:p>
-                      <a:r>
-                        <a:rPr sz="1875" b="0">
-                          <a:solidFill>
-                            <a:srgbClr val="1C302B"/>
-                          </a:solidFill>
-                          <a:latin typeface="Helvetica Neue"/>
-                          <a:ea typeface="Helvetica Neue"/>
-                          <a:cs typeface="Helvetica Neue"/>
-                        </a:rPr>
-                        <a:t>MCP did not deliver the full native experience</a:t>
-                      </a:r>
-                    </a:p>
-                  </a:txBody>
-                  <a:tcPr marL="152400" marR="152400" marT="114300" marB="95250" anchor="ctr">
-                    <a:solidFill>
-                      <a:srgbClr val="F4F1E7"/>
-                    </a:solidFill>
-                  </a:tcPr>
-                </a:tc>
-                <a:tc>
-                  <a:txBody>
-                    <a:bodyPr>
-                      <a:noAutofit/>
-                    </a:bodyPr>
-                    <a:lstStyle/>
-                    <a:p>
-                      <a:r>
-                        <a:rPr sz="1875" b="0">
-                          <a:solidFill>
-                            <a:srgbClr val="1C302B"/>
-                          </a:solidFill>
-                          <a:latin typeface="Helvetica Neue"/>
-                          <a:ea typeface="Helvetica Neue"/>
-                          <a:cs typeface="Helvetica Neue"/>
-                        </a:rPr>
-                        <a:t>Full Codex plugin package and explicit scope boundary</a:t>
-                      </a:r>
-                    </a:p>
-                  </a:txBody>
-                  <a:tcPr marL="152400" marR="152400" marT="114300" marB="95250" anchor="ctr">
-                    <a:solidFill>
-                      <a:srgbClr val="F4F1E7"/>
-                    </a:solidFill>
-                  </a:tcPr>
-                </a:tc>
-              </a:tr>
-              <a:tr h="757238">
-                <a:tc>
-                  <a:txBody>
-                    <a:bodyPr>
-                      <a:noAutofit/>
-                    </a:bodyPr>
-                    <a:lstStyle/>
-                    <a:p>
-                      <a:r>
-                        <a:rPr sz="1875" b="0">
-                          <a:solidFill>
-                            <a:srgbClr val="1C302B"/>
-                          </a:solidFill>
-                          <a:latin typeface="Helvetica Neue"/>
-                          <a:ea typeface="Helvetica Neue"/>
-                          <a:cs typeface="Helvetica Neue"/>
-                        </a:rPr>
-                        <a:t>Grill Me naming varied after reinstall</a:t>
-                      </a:r>
-                    </a:p>
-                  </a:txBody>
-                  <a:tcPr marL="152400" marR="152400" marT="114300" marB="95250" anchor="ctr">
-                    <a:solidFill>
-                      <a:srgbClr val="E8EDE3"/>
-                    </a:solidFill>
-                  </a:tcPr>
-                </a:tc>
-                <a:tc>
-                  <a:txBody>
-                    <a:bodyPr>
-                      <a:noAutofit/>
-                    </a:bodyPr>
-                    <a:lstStyle/>
-                    <a:p>
-                      <a:r>
-                        <a:rPr sz="1875" b="0">
-                          <a:solidFill>
-                            <a:srgbClr val="1C302B"/>
-                          </a:solidFill>
-                          <a:latin typeface="Helvetica Neue"/>
-                          <a:ea typeface="Helvetica Neue"/>
-                          <a:cs typeface="Helvetica Neue"/>
-                        </a:rPr>
-                        <a:t>Preserved the public $grill-me name</a:t>
-                      </a:r>
-                    </a:p>
-                  </a:txBody>
-                  <a:tcPr marL="152400" marR="152400" marT="114300" marB="95250" anchor="ctr">
-                    <a:solidFill>
-                      <a:srgbClr val="E8EDE3"/>
-                    </a:solidFill>
-                  </a:tcPr>
-                </a:tc>
-              </a:tr>
-              <a:tr h="757238">
-                <a:tc>
-                  <a:txBody>
-                    <a:bodyPr>
-                      <a:noAutofit/>
-                    </a:bodyPr>
-                    <a:lstStyle/>
-                    <a:p>
-                      <a:r>
-                        <a:rPr sz="1875" b="0">
-                          <a:solidFill>
-                            <a:srgbClr val="1C302B"/>
-                          </a:solidFill>
-                          <a:latin typeface="Helvetica Neue"/>
-                          <a:ea typeface="Helvetica Neue"/>
-                          <a:cs typeface="Helvetica Neue"/>
-                        </a:rPr>
-                        <a:t>Repeated setup and approval friction</a:t>
-                      </a:r>
-                    </a:p>
-                  </a:txBody>
-                  <a:tcPr marL="152400" marR="152400" marT="114300" marB="95250" anchor="ctr">
-                    <a:solidFill>
-                      <a:srgbClr val="F4F1E7"/>
-                    </a:solidFill>
-                  </a:tcPr>
-                </a:tc>
-                <a:tc>
-                  <a:txBody>
-                    <a:bodyPr>
-                      <a:noAutofit/>
-                    </a:bodyPr>
-                    <a:lstStyle/>
-                    <a:p>
-                      <a:r>
-                        <a:rPr sz="1875" b="0">
-                          <a:solidFill>
-                            <a:srgbClr val="1C302B"/>
-                          </a:solidFill>
-                          <a:latin typeface="Helvetica Neue"/>
-                          <a:ea typeface="Helvetica Neue"/>
-                          <a:cs typeface="Helvetica Neue"/>
-                        </a:rPr>
-                        <a:t>Clearer installation guidance and human-control boundaries</a:t>
-                      </a:r>
-                    </a:p>
-                  </a:txBody>
-                  <a:tcPr marL="152400" marR="152400" marT="114300" marB="95250" anchor="ctr">
-                    <a:solidFill>
-                      <a:srgbClr val="F4F1E7"/>
-                    </a:solidFill>
-                  </a:tcPr>
-                </a:tc>
-              </a:tr>
-            </a:tbl>
-          </a:graphicData>
-        </a:graphic>
-      </p:graphicFrame>
-      <p:sp>
-        <p:nvSpPr>
-          <p:cNvPr id="5" name="">
-            <a:extLst xmlns:a="http://schemas.openxmlformats.org/drawingml/2006/main">
-              <a:ext uri="{FF2B5EF4-FFF2-40B4-BE49-F238E27FC236}">
-                <a16:creationId xmlns:a16="http://schemas.microsoft.com/office/drawing/2014/main" id="{A9CBF637-DF78-4553-8599-1DA769819D8F}"/>
-              </a:ext>
-            </a:extLst>
-          </p:cNvPr>
-          <p:cNvSpPr>
-            <a:spLocks xmlns:a="http://schemas.openxmlformats.org/drawingml/2006/main" noGrp="1"/>
-          </p:cNvSpPr>
-          <p:nvPr/>
-        </p:nvSpPr>
-        <p:spPr>
-          <a:xfrm xmlns:a="http://schemas.openxmlformats.org/drawingml/2006/main">
-            <a:off x="619125" y="5562600"/>
-            <a:ext cx="10763250" cy="790575"/>
-          </a:xfrm>
-          <a:prstGeom xmlns:a="http://schemas.openxmlformats.org/drawingml/2006/main" prst="rect">
-            <a:avLst/>
-          </a:prstGeom>
-          <a:noFill xmlns:a="http://schemas.openxmlformats.org/drawingml/2006/main"/>
-          <a:ln xmlns:a="http://schemas.openxmlformats.org/drawingml/2006/main" w="0">
-            <a:noFill/>
-          </a:ln>
-        </p:spPr>
-        <p:txBody>
-          <a:bodyPr xmlns:a="http://schemas.openxmlformats.org/drawingml/2006/main">
-            <a:noAutofit/>
-          </a:bodyPr>
-          <a:lstStyle xmlns:a="http://schemas.openxmlformats.org/drawingml/2006/main"/>
-          <a:p xmlns:a="http://schemas.openxmlformats.org/drawingml/2006/main">
-            <a:pPr>
-              <a:defRPr sz="2025" b="1">
-                <a:solidFill>
-                  <a:srgbClr val="173F35"/>
-                </a:solidFill>
-                <a:latin typeface="Helvetica Neue"/>
-                <a:ea typeface="Helvetica Neue"/>
-                <a:cs typeface="Helvetica Neue"/>
-              </a:defRPr>
-            </a:pPr>
-            <a:r>
-              <a:rPr sz="2025" b="1">
-                <a:solidFill>
-                  <a:srgbClr val="173F35"/>
-                </a:solidFill>
-                <a:latin typeface="Helvetica Neue"/>
-                <a:ea typeface="Helvetica Neue"/>
-                <a:cs typeface="Helvetica Neue"/>
-              </a:rPr>
-              <a:t>Next: observe independent PMs complete a first workflow.</a:t>
-            </a:r>
-          </a:p>
-          <a:p xmlns:a="http://schemas.openxmlformats.org/drawingml/2006/main">
-            <a:pPr>
-              <a:defRPr sz="2025" b="1">
-                <a:solidFill>
-                  <a:srgbClr val="173F35"/>
-                </a:solidFill>
-                <a:latin typeface="Helvetica Neue"/>
-                <a:ea typeface="Helvetica Neue"/>
-                <a:cs typeface="Helvetica Neue"/>
-              </a:defRPr>
-            </a:pPr>
-            <a:r>
-              <a:rPr sz="2025" b="1">
-                <a:solidFill>
-                  <a:srgbClr val="173F35"/>
-                </a:solidFill>
-                <a:latin typeface="Helvetica Neue"/>
-                <a:ea typeface="Helvetica Neue"/>
-                <a:cs typeface="Helvetica Neue"/>
-              </a:rPr>
-              <a:t>Measure setup success, clarification quality and control over decisions.</a:t>
-            </a:r>
-          </a:p>
-        </p:txBody>
-      </p:sp>
-    </p:spTree>
-    <p:extLst>
-      <p:ext uri="{BB962C8B-B14F-4D97-AF65-F5344CB8AC3E}">
-        <p14:creationId xmlns:p14="http://schemas.microsoft.com/office/powerpoint/2010/main" val="1174218499"/>
-      </p:ext>
-    </p:extLst>
-  </p:cSld>
-</p:sld>
-</file>
-
-<file path=ppt/slides/slide12.xml><?xml version="1.0" encoding="utf-8"?>
-<p:sld xmlns:p="http://schemas.openxmlformats.org/presentationml/2006/main">
-  <p:cSld>
-    <p:bg>
-      <p:bgPr>
-        <a:solidFill xmlns:a="http://schemas.openxmlformats.org/drawingml/2006/main">
-          <a:srgbClr val="F4F1E7"/>
-        </a:solidFill>
-      </p:bgPr>
-    </p:bg>
-    <p:spTree>
-      <p:nvGrpSpPr>
-        <p:cNvPr id="1" name=""/>
-        <p:cNvGrpSpPr/>
-        <p:nvPr/>
-      </p:nvGrpSpPr>
-      <p:grpSpPr>
-        <a:xfrm xmlns:a="http://schemas.openxmlformats.org/drawingml/2006/main"/>
-      </p:grpSpPr>
-      <p:sp>
-        <p:nvSpPr>
-          <p:cNvPr id="9" name="">
-            <a:extLst xmlns:a="http://schemas.openxmlformats.org/drawingml/2006/main">
-              <a:ext uri="{FF2B5EF4-FFF2-40B4-BE49-F238E27FC236}">
-                <a16:creationId xmlns:a16="http://schemas.microsoft.com/office/drawing/2014/main" id="{565215DB-8F3F-4C3C-8EA5-E0E48AFD4CC8}"/>
-              </a:ext>
-            </a:extLst>
-          </p:cNvPr>
-          <p:cNvSpPr>
-            <a:spLocks xmlns:a="http://schemas.openxmlformats.org/drawingml/2006/main" noGrp="1"/>
-          </p:cNvSpPr>
-          <p:nvPr/>
-        </p:nvSpPr>
-        <p:spPr>
-          <a:xfrm xmlns:a="http://schemas.openxmlformats.org/drawingml/2006/main">
-            <a:off x="609600" y="476250"/>
-            <a:ext cx="10953750" cy="914400"/>
-          </a:xfrm>
-          <a:prstGeom xmlns:a="http://schemas.openxmlformats.org/drawingml/2006/main" prst="rect">
-            <a:avLst/>
-          </a:prstGeom>
-          <a:noFill xmlns:a="http://schemas.openxmlformats.org/drawingml/2006/main"/>
-          <a:ln xmlns:a="http://schemas.openxmlformats.org/drawingml/2006/main" w="0">
-            <a:noFill/>
-          </a:ln>
-        </p:spPr>
-        <p:txBody>
-          <a:bodyPr xmlns:a="http://schemas.openxmlformats.org/drawingml/2006/main">
-            <a:noAutofit/>
-          </a:bodyPr>
-          <a:lstStyle xmlns:a="http://schemas.openxmlformats.org/drawingml/2006/main"/>
-          <a:p xmlns:a="http://schemas.openxmlformats.org/drawingml/2006/main">
-            <a:pPr>
-              <a:defRPr sz="3450" b="1">
-                <a:solidFill>
-                  <a:srgbClr val="173F35"/>
-                </a:solidFill>
-                <a:latin typeface="Helvetica Neue"/>
-                <a:ea typeface="Helvetica Neue"/>
-                <a:cs typeface="Helvetica Neue"/>
-              </a:defRPr>
-            </a:pPr>
-            <a:r>
-              <a:rPr sz="3450" b="1">
-                <a:solidFill>
-                  <a:srgbClr val="173F35"/>
-                </a:solidFill>
-                <a:latin typeface="Helvetica Neue"/>
-                <a:ea typeface="Helvetica Neue"/>
-                <a:cs typeface="Helvetica Neue"/>
-              </a:rPr>
-              <a:t>Current status and learning priorities</a:t>
-            </a:r>
-          </a:p>
-        </p:txBody>
-      </p:sp>
-      <p:sp>
-        <p:nvSpPr>
-          <p:cNvPr id="2" name="">
-            <a:extLst xmlns:a="http://schemas.openxmlformats.org/drawingml/2006/main">
-              <a:ext uri="{FF2B5EF4-FFF2-40B4-BE49-F238E27FC236}">
-                <a16:creationId xmlns:a16="http://schemas.microsoft.com/office/drawing/2014/main" id="{F5A35721-3437-43B6-890F-47A77FE657DC}"/>
-              </a:ext>
-            </a:extLst>
-          </p:cNvPr>
-          <p:cNvSpPr>
-            <a:spLocks xmlns:a="http://schemas.openxmlformats.org/drawingml/2006/main" noGrp="1"/>
-          </p:cNvSpPr>
-          <p:nvPr/>
-        </p:nvSpPr>
-        <p:spPr>
-          <a:xfrm xmlns:a="http://schemas.openxmlformats.org/drawingml/2006/main">
-            <a:off x="11144250" y="6315075"/>
-            <a:ext cx="457200" cy="257175"/>
-          </a:xfrm>
-          <a:prstGeom xmlns:a="http://schemas.openxmlformats.org/drawingml/2006/main" prst="rect">
-            <a:avLst/>
-          </a:prstGeom>
-          <a:noFill xmlns:a="http://schemas.openxmlformats.org/drawingml/2006/main"/>
-          <a:ln xmlns:a="http://schemas.openxmlformats.org/drawingml/2006/main" w="0">
-            <a:noFill/>
-          </a:ln>
-        </p:spPr>
-        <p:txBody>
-          <a:bodyPr xmlns:a="http://schemas.openxmlformats.org/drawingml/2006/main">
-            <a:noAutofit/>
-          </a:bodyPr>
-          <a:lstStyle xmlns:a="http://schemas.openxmlformats.org/drawingml/2006/main"/>
-          <a:p xmlns:a="http://schemas.openxmlformats.org/drawingml/2006/main">
-            <a:pPr>
-              <a:defRPr sz="1350" b="0">
-                <a:solidFill>
-                  <a:srgbClr val="66756B"/>
-                </a:solidFill>
-                <a:latin typeface="Helvetica Neue"/>
-                <a:ea typeface="Helvetica Neue"/>
-                <a:cs typeface="Helvetica Neue"/>
-              </a:defRPr>
-            </a:pPr>
-            <a:r>
-              <a:rPr sz="1350" b="0">
-                <a:solidFill>
-                  <a:srgbClr val="66756B"/>
-                </a:solidFill>
-                <a:latin typeface="Helvetica Neue"/>
-                <a:ea typeface="Helvetica Neue"/>
-                <a:cs typeface="Helvetica Neue"/>
-              </a:rPr>
-              <a:t>12</a:t>
-            </a:r>
-          </a:p>
-        </p:txBody>
-      </p:sp>
-      <p:sp>
-        <p:nvSpPr>
-          <p:cNvPr id="3" name="">
-            <a:extLst xmlns:a="http://schemas.openxmlformats.org/drawingml/2006/main">
-              <a:ext uri="{FF2B5EF4-FFF2-40B4-BE49-F238E27FC236}">
-                <a16:creationId xmlns:a16="http://schemas.microsoft.com/office/drawing/2014/main" id="{16B9FEB9-85F1-4D67-8E8A-6A2090D1CABD}"/>
+                <a16:creationId xmlns:a16="http://schemas.microsoft.com/office/drawing/2014/main" id="{65BF27E2-9009-4DFD-A5DB-27F22E0A9C3D}"/>
               </a:ext>
             </a:extLst>
           </p:cNvPr>
@@ -3561,7 +2231,7 @@
           <p:cNvPr id="4" name="">
             <a:extLst xmlns:a="http://schemas.openxmlformats.org/drawingml/2006/main">
               <a:ext uri="{FF2B5EF4-FFF2-40B4-BE49-F238E27FC236}">
-                <a16:creationId xmlns:a16="http://schemas.microsoft.com/office/drawing/2014/main" id="{A8D371AF-1E2F-4E01-9F15-BED85267E1A0}"/>
+                <a16:creationId xmlns:a16="http://schemas.microsoft.com/office/drawing/2014/main" id="{76552922-32D4-405E-A547-08F0BF058E99}"/>
               </a:ext>
             </a:extLst>
           </p:cNvPr>
@@ -3664,7 +2334,7 @@
           <p:cNvPr id="5" name="">
             <a:extLst xmlns:a="http://schemas.openxmlformats.org/drawingml/2006/main">
               <a:ext uri="{FF2B5EF4-FFF2-40B4-BE49-F238E27FC236}">
-                <a16:creationId xmlns:a16="http://schemas.microsoft.com/office/drawing/2014/main" id="{EF26EDA0-AE75-45C2-B679-14F321B8ECED}"/>
+                <a16:creationId xmlns:a16="http://schemas.microsoft.com/office/drawing/2014/main" id="{55563DC7-25E0-409D-9D33-6A12CF18F0F2}"/>
               </a:ext>
             </a:extLst>
           </p:cNvPr>
@@ -3721,7 +2391,7 @@
           <p:cNvPr id="6" name="">
             <a:extLst xmlns:a="http://schemas.openxmlformats.org/drawingml/2006/main">
               <a:ext uri="{FF2B5EF4-FFF2-40B4-BE49-F238E27FC236}">
-                <a16:creationId xmlns:a16="http://schemas.microsoft.com/office/drawing/2014/main" id="{C4A1B733-B23A-4F52-A7B4-DAD02041B5A5}"/>
+                <a16:creationId xmlns:a16="http://schemas.microsoft.com/office/drawing/2014/main" id="{244DA9B1-05F2-49CE-9C82-2C58C4DDE3E1}"/>
               </a:ext>
             </a:extLst>
           </p:cNvPr>
@@ -3801,7 +2471,7 @@
           <p:cNvPr id="7" name="">
             <a:extLst xmlns:a="http://schemas.openxmlformats.org/drawingml/2006/main">
               <a:ext uri="{FF2B5EF4-FFF2-40B4-BE49-F238E27FC236}">
-                <a16:creationId xmlns:a16="http://schemas.microsoft.com/office/drawing/2014/main" id="{8FD038FE-4A5F-46C9-B07F-6F49D7E9D0CA}"/>
+                <a16:creationId xmlns:a16="http://schemas.microsoft.com/office/drawing/2014/main" id="{78895197-A2D2-4831-8954-14172A185552}"/>
               </a:ext>
             </a:extLst>
           </p:cNvPr>
@@ -3858,7 +2528,7 @@
           <p:cNvPr id="8" name="">
             <a:extLst xmlns:a="http://schemas.openxmlformats.org/drawingml/2006/main">
               <a:ext uri="{FF2B5EF4-FFF2-40B4-BE49-F238E27FC236}">
-                <a16:creationId xmlns:a16="http://schemas.microsoft.com/office/drawing/2014/main" id="{E09E7C32-A149-4856-B3D4-17F26C1DFC45}"/>
+                <a16:creationId xmlns:a16="http://schemas.microsoft.com/office/drawing/2014/main" id="{B7307DE2-D3B5-4374-A23B-890F7B53FD5F}"/>
               </a:ext>
             </a:extLst>
           </p:cNvPr>
@@ -3959,515 +2629,7 @@
     </p:spTree>
     <p:extLst>
       <p:ext uri="{BB962C8B-B14F-4D97-AF65-F5344CB8AC3E}">
-        <p14:creationId xmlns:p14="http://schemas.microsoft.com/office/powerpoint/2010/main" val="518585234"/>
-      </p:ext>
-    </p:extLst>
-  </p:cSld>
-</p:sld>
-</file>
-
-<file path=ppt/slides/slide13.xml><?xml version="1.0" encoding="utf-8"?>
-<p:sld xmlns:p="http://schemas.openxmlformats.org/presentationml/2006/main">
-  <p:cSld>
-    <p:bg>
-      <p:bgPr>
-        <a:solidFill xmlns:a="http://schemas.openxmlformats.org/drawingml/2006/main">
-          <a:srgbClr val="173F35"/>
-        </a:solidFill>
-      </p:bgPr>
-    </p:bg>
-    <p:spTree>
-      <p:nvGrpSpPr>
-        <p:cNvPr id="1" name=""/>
-        <p:cNvGrpSpPr/>
-        <p:nvPr/>
-      </p:nvGrpSpPr>
-      <p:grpSpPr>
-        <a:xfrm xmlns:a="http://schemas.openxmlformats.org/drawingml/2006/main"/>
-      </p:grpSpPr>
-      <p:sp>
-        <p:nvSpPr>
-          <p:cNvPr id="9" name="">
-            <a:extLst xmlns:a="http://schemas.openxmlformats.org/drawingml/2006/main">
-              <a:ext uri="{FF2B5EF4-FFF2-40B4-BE49-F238E27FC236}">
-                <a16:creationId xmlns:a16="http://schemas.microsoft.com/office/drawing/2014/main" id="{080408A1-8716-47EC-A26E-7653DCF58D52}"/>
-              </a:ext>
-            </a:extLst>
-          </p:cNvPr>
-          <p:cNvSpPr>
-            <a:spLocks xmlns:a="http://schemas.openxmlformats.org/drawingml/2006/main" noGrp="1"/>
-          </p:cNvSpPr>
-          <p:nvPr/>
-        </p:nvSpPr>
-        <p:spPr>
-          <a:xfrm xmlns:a="http://schemas.openxmlformats.org/drawingml/2006/main">
-            <a:off x="609600" y="476250"/>
-            <a:ext cx="10953750" cy="914400"/>
-          </a:xfrm>
-          <a:prstGeom xmlns:a="http://schemas.openxmlformats.org/drawingml/2006/main" prst="rect">
-            <a:avLst/>
-          </a:prstGeom>
-          <a:noFill xmlns:a="http://schemas.openxmlformats.org/drawingml/2006/main"/>
-          <a:ln xmlns:a="http://schemas.openxmlformats.org/drawingml/2006/main" w="0">
-            <a:noFill/>
-          </a:ln>
-        </p:spPr>
-        <p:txBody>
-          <a:bodyPr xmlns:a="http://schemas.openxmlformats.org/drawingml/2006/main">
-            <a:noAutofit/>
-          </a:bodyPr>
-          <a:lstStyle xmlns:a="http://schemas.openxmlformats.org/drawingml/2006/main"/>
-          <a:p xmlns:a="http://schemas.openxmlformats.org/drawingml/2006/main">
-            <a:pPr>
-              <a:defRPr sz="3450" b="1">
-                <a:solidFill>
-                  <a:srgbClr val="F4F1E7"/>
-                </a:solidFill>
-                <a:latin typeface="Helvetica Neue"/>
-                <a:ea typeface="Helvetica Neue"/>
-                <a:cs typeface="Helvetica Neue"/>
-              </a:defRPr>
-            </a:pPr>
-            <a:r>
-              <a:rPr sz="3450" b="1">
-                <a:solidFill>
-                  <a:srgbClr val="F4F1E7"/>
-                </a:solidFill>
-                <a:latin typeface="Helvetica Neue"/>
-                <a:ea typeface="Helvetica Neue"/>
-                <a:cs typeface="Helvetica Neue"/>
-              </a:rPr>
-              <a:t>Getting started</a:t>
-            </a:r>
-          </a:p>
-        </p:txBody>
-      </p:sp>
-      <p:sp>
-        <p:nvSpPr>
-          <p:cNvPr id="2" name="">
-            <a:extLst xmlns:a="http://schemas.openxmlformats.org/drawingml/2006/main">
-              <a:ext uri="{FF2B5EF4-FFF2-40B4-BE49-F238E27FC236}">
-                <a16:creationId xmlns:a16="http://schemas.microsoft.com/office/drawing/2014/main" id="{57BC2AFF-B45B-4D0A-B1A6-CE9BE4F49DE7}"/>
-              </a:ext>
-            </a:extLst>
-          </p:cNvPr>
-          <p:cNvSpPr>
-            <a:spLocks xmlns:a="http://schemas.openxmlformats.org/drawingml/2006/main" noGrp="1"/>
-          </p:cNvSpPr>
-          <p:nvPr/>
-        </p:nvSpPr>
-        <p:spPr>
-          <a:xfrm xmlns:a="http://schemas.openxmlformats.org/drawingml/2006/main">
-            <a:off x="11144250" y="6315075"/>
-            <a:ext cx="457200" cy="257175"/>
-          </a:xfrm>
-          <a:prstGeom xmlns:a="http://schemas.openxmlformats.org/drawingml/2006/main" prst="rect">
-            <a:avLst/>
-          </a:prstGeom>
-          <a:noFill xmlns:a="http://schemas.openxmlformats.org/drawingml/2006/main"/>
-          <a:ln xmlns:a="http://schemas.openxmlformats.org/drawingml/2006/main" w="0">
-            <a:noFill/>
-          </a:ln>
-        </p:spPr>
-        <p:txBody>
-          <a:bodyPr xmlns:a="http://schemas.openxmlformats.org/drawingml/2006/main">
-            <a:noAutofit/>
-          </a:bodyPr>
-          <a:lstStyle xmlns:a="http://schemas.openxmlformats.org/drawingml/2006/main"/>
-          <a:p xmlns:a="http://schemas.openxmlformats.org/drawingml/2006/main">
-            <a:pPr>
-              <a:defRPr sz="1350" b="0">
-                <a:solidFill>
-                  <a:srgbClr val="D8E5DA"/>
-                </a:solidFill>
-                <a:latin typeface="Helvetica Neue"/>
-                <a:ea typeface="Helvetica Neue"/>
-                <a:cs typeface="Helvetica Neue"/>
-              </a:defRPr>
-            </a:pPr>
-            <a:r>
-              <a:rPr sz="1350" b="0">
-                <a:solidFill>
-                  <a:srgbClr val="D8E5DA"/>
-                </a:solidFill>
-                <a:latin typeface="Helvetica Neue"/>
-                <a:ea typeface="Helvetica Neue"/>
-                <a:cs typeface="Helvetica Neue"/>
-              </a:rPr>
-              <a:t>13</a:t>
-            </a:r>
-          </a:p>
-        </p:txBody>
-      </p:sp>
-      <p:sp>
-        <p:nvSpPr>
-          <p:cNvPr id="3" name="">
-            <a:extLst xmlns:a="http://schemas.openxmlformats.org/drawingml/2006/main">
-              <a:ext uri="{FF2B5EF4-FFF2-40B4-BE49-F238E27FC236}">
-                <a16:creationId xmlns:a16="http://schemas.microsoft.com/office/drawing/2014/main" id="{5FCEEE09-E188-4F8A-AFA1-2EA71A386008}"/>
-              </a:ext>
-            </a:extLst>
-          </p:cNvPr>
-          <p:cNvSpPr>
-            <a:spLocks xmlns:a="http://schemas.openxmlformats.org/drawingml/2006/main" noGrp="1"/>
-          </p:cNvSpPr>
-          <p:nvPr/>
-        </p:nvSpPr>
-        <p:spPr>
-          <a:xfrm xmlns:a="http://schemas.openxmlformats.org/drawingml/2006/main">
-            <a:off x="619125" y="1609725"/>
-            <a:ext cx="10763250" cy="523875"/>
-          </a:xfrm>
-          <a:prstGeom xmlns:a="http://schemas.openxmlformats.org/drawingml/2006/main" prst="rect">
-            <a:avLst/>
-          </a:prstGeom>
-          <a:noFill xmlns:a="http://schemas.openxmlformats.org/drawingml/2006/main"/>
-          <a:ln xmlns:a="http://schemas.openxmlformats.org/drawingml/2006/main" w="0">
-            <a:noFill/>
-          </a:ln>
-        </p:spPr>
-        <p:txBody>
-          <a:bodyPr xmlns:a="http://schemas.openxmlformats.org/drawingml/2006/main">
-            <a:noAutofit/>
-          </a:bodyPr>
-          <a:lstStyle xmlns:a="http://schemas.openxmlformats.org/drawingml/2006/main"/>
-          <a:p xmlns:a="http://schemas.openxmlformats.org/drawingml/2006/main">
-            <a:pPr>
-              <a:defRPr sz="2625" b="1">
-                <a:solidFill>
-                  <a:srgbClr val="F4F1E7"/>
-                </a:solidFill>
-                <a:latin typeface="Helvetica Neue"/>
-                <a:ea typeface="Helvetica Neue"/>
-                <a:cs typeface="Helvetica Neue"/>
-              </a:defRPr>
-            </a:pPr>
-            <a:r>
-              <a:rPr sz="2625" b="1">
-                <a:solidFill>
-                  <a:srgbClr val="F4F1E7"/>
-                </a:solidFill>
-                <a:latin typeface="Helvetica Neue"/>
-                <a:ea typeface="Helvetica Neue"/>
-                <a:cs typeface="Helvetica Neue"/>
-              </a:rPr>
-              <a:t>github.com/VandanaAjayDubey111/great-pm</a:t>
-            </a:r>
-          </a:p>
-        </p:txBody>
-      </p:sp>
-      <p:sp>
-        <p:nvSpPr>
-          <p:cNvPr id="4" name="">
-            <a:extLst xmlns:a="http://schemas.openxmlformats.org/drawingml/2006/main">
-              <a:ext uri="{FF2B5EF4-FFF2-40B4-BE49-F238E27FC236}">
-                <a16:creationId xmlns:a16="http://schemas.microsoft.com/office/drawing/2014/main" id="{75F55AB0-1C9A-4576-812A-F529A298F897}"/>
-              </a:ext>
-            </a:extLst>
-          </p:cNvPr>
-          <p:cNvSpPr>
-            <a:spLocks xmlns:a="http://schemas.openxmlformats.org/drawingml/2006/main" noGrp="1"/>
-          </p:cNvSpPr>
-          <p:nvPr/>
-        </p:nvSpPr>
-        <p:spPr>
-          <a:xfrm xmlns:a="http://schemas.openxmlformats.org/drawingml/2006/main">
-            <a:off x="619125" y="2647950"/>
-            <a:ext cx="10763250" cy="409575"/>
-          </a:xfrm>
-          <a:prstGeom xmlns:a="http://schemas.openxmlformats.org/drawingml/2006/main" prst="rect">
-            <a:avLst/>
-          </a:prstGeom>
-          <a:noFill xmlns:a="http://schemas.openxmlformats.org/drawingml/2006/main"/>
-          <a:ln xmlns:a="http://schemas.openxmlformats.org/drawingml/2006/main" w="0">
-            <a:noFill/>
-          </a:ln>
-        </p:spPr>
-        <p:txBody>
-          <a:bodyPr xmlns:a="http://schemas.openxmlformats.org/drawingml/2006/main">
-            <a:noAutofit/>
-          </a:bodyPr>
-          <a:lstStyle xmlns:a="http://schemas.openxmlformats.org/drawingml/2006/main"/>
-          <a:p xmlns:a="http://schemas.openxmlformats.org/drawingml/2006/main">
-            <a:pPr>
-              <a:defRPr sz="2025" b="1">
-                <a:solidFill>
-                  <a:srgbClr val="D8E5DA"/>
-                </a:solidFill>
-                <a:latin typeface="Helvetica Neue"/>
-                <a:ea typeface="Helvetica Neue"/>
-                <a:cs typeface="Helvetica Neue"/>
-              </a:defRPr>
-            </a:pPr>
-            <a:r>
-              <a:rPr sz="2025" b="1">
-                <a:solidFill>
-                  <a:srgbClr val="D8E5DA"/>
-                </a:solidFill>
-                <a:latin typeface="Helvetica Neue"/>
-                <a:ea typeface="Helvetica Neue"/>
-                <a:cs typeface="Helvetica Neue"/>
-              </a:rPr>
-              <a:t>Codex installation</a:t>
-            </a:r>
-          </a:p>
-        </p:txBody>
-      </p:sp>
-      <p:sp>
-        <p:nvSpPr>
-          <p:cNvPr id="5" name="">
-            <a:extLst xmlns:a="http://schemas.openxmlformats.org/drawingml/2006/main">
-              <a:ext uri="{FF2B5EF4-FFF2-40B4-BE49-F238E27FC236}">
-                <a16:creationId xmlns:a16="http://schemas.microsoft.com/office/drawing/2014/main" id="{0D0939BA-9132-4896-9A63-CA9D77414BA5}"/>
-              </a:ext>
-            </a:extLst>
-          </p:cNvPr>
-          <p:cNvSpPr>
-            <a:spLocks xmlns:a="http://schemas.openxmlformats.org/drawingml/2006/main" noGrp="1"/>
-          </p:cNvSpPr>
-          <p:nvPr/>
-        </p:nvSpPr>
-        <p:spPr>
-          <a:xfrm xmlns:a="http://schemas.openxmlformats.org/drawingml/2006/main">
-            <a:off x="619125" y="3209925"/>
-            <a:ext cx="10953750" cy="952500"/>
-          </a:xfrm>
-          <a:prstGeom xmlns:a="http://schemas.openxmlformats.org/drawingml/2006/main" prst="rect">
-            <a:avLst/>
-          </a:prstGeom>
-          <a:noFill xmlns:a="http://schemas.openxmlformats.org/drawingml/2006/main"/>
-          <a:ln xmlns:a="http://schemas.openxmlformats.org/drawingml/2006/main" w="0">
-            <a:noFill/>
-          </a:ln>
-        </p:spPr>
-        <p:txBody>
-          <a:bodyPr xmlns:a="http://schemas.openxmlformats.org/drawingml/2006/main">
-            <a:noAutofit/>
-          </a:bodyPr>
-          <a:lstStyle xmlns:a="http://schemas.openxmlformats.org/drawingml/2006/main"/>
-          <a:p xmlns:a="http://schemas.openxmlformats.org/drawingml/2006/main">
-            <a:pPr>
-              <a:defRPr sz="2025" b="0">
-                <a:solidFill>
-                  <a:srgbClr val="F4F1E7"/>
-                </a:solidFill>
-                <a:latin typeface="Helvetica Neue"/>
-                <a:ea typeface="Helvetica Neue"/>
-                <a:cs typeface="Helvetica Neue"/>
-              </a:defRPr>
-            </a:pPr>
-            <a:r>
-              <a:rPr sz="2025" b="0">
-                <a:solidFill>
-                  <a:srgbClr val="F4F1E7"/>
-                </a:solidFill>
-                <a:latin typeface="Helvetica Neue"/>
-                <a:ea typeface="Helvetica Neue"/>
-                <a:cs typeface="Helvetica Neue"/>
-              </a:rPr>
-              <a:t>codex plugin marketplace add VandanaAjayDubey111/great-pm</a:t>
-            </a:r>
-          </a:p>
-          <a:p xmlns:a="http://schemas.openxmlformats.org/drawingml/2006/main">
-            <a:pPr>
-              <a:defRPr sz="2025" b="0">
-                <a:solidFill>
-                  <a:srgbClr val="F4F1E7"/>
-                </a:solidFill>
-                <a:latin typeface="Helvetica Neue"/>
-                <a:ea typeface="Helvetica Neue"/>
-                <a:cs typeface="Helvetica Neue"/>
-              </a:defRPr>
-            </a:pPr>
-            <a:r>
-              <a:rPr sz="2025" b="0">
-                <a:solidFill>
-                  <a:srgbClr val="F4F1E7"/>
-                </a:solidFill>
-                <a:latin typeface="Helvetica Neue"/>
-                <a:ea typeface="Helvetica Neue"/>
-                <a:cs typeface="Helvetica Neue"/>
-              </a:rPr>
-              <a:t>codex plugin add great-pm@great-pm</a:t>
-            </a:r>
-          </a:p>
-        </p:txBody>
-      </p:sp>
-      <p:sp>
-        <p:nvSpPr>
-          <p:cNvPr id="6" name="">
-            <a:extLst xmlns:a="http://schemas.openxmlformats.org/drawingml/2006/main">
-              <a:ext uri="{FF2B5EF4-FFF2-40B4-BE49-F238E27FC236}">
-                <a16:creationId xmlns:a16="http://schemas.microsoft.com/office/drawing/2014/main" id="{640BBF08-19A5-4863-8502-C58EE6D17F82}"/>
-              </a:ext>
-            </a:extLst>
-          </p:cNvPr>
-          <p:cNvSpPr>
-            <a:spLocks xmlns:a="http://schemas.openxmlformats.org/drawingml/2006/main" noGrp="1"/>
-          </p:cNvSpPr>
-          <p:nvPr/>
-        </p:nvSpPr>
-        <p:spPr>
-          <a:xfrm xmlns:a="http://schemas.openxmlformats.org/drawingml/2006/main">
-            <a:off x="619125" y="4505325"/>
-            <a:ext cx="10763250" cy="523875"/>
-          </a:xfrm>
-          <a:prstGeom xmlns:a="http://schemas.openxmlformats.org/drawingml/2006/main" prst="rect">
-            <a:avLst/>
-          </a:prstGeom>
-          <a:noFill xmlns:a="http://schemas.openxmlformats.org/drawingml/2006/main"/>
-          <a:ln xmlns:a="http://schemas.openxmlformats.org/drawingml/2006/main" w="0">
-            <a:noFill/>
-          </a:ln>
-        </p:spPr>
-        <p:txBody>
-          <a:bodyPr xmlns:a="http://schemas.openxmlformats.org/drawingml/2006/main">
-            <a:noAutofit/>
-          </a:bodyPr>
-          <a:lstStyle xmlns:a="http://schemas.openxmlformats.org/drawingml/2006/main"/>
-          <a:p xmlns:a="http://schemas.openxmlformats.org/drawingml/2006/main">
-            <a:pPr>
-              <a:defRPr sz="2250" b="1">
-                <a:solidFill>
-                  <a:srgbClr val="F4F1E7"/>
-                </a:solidFill>
-                <a:latin typeface="Helvetica Neue"/>
-                <a:ea typeface="Helvetica Neue"/>
-                <a:cs typeface="Helvetica Neue"/>
-              </a:defRPr>
-            </a:pPr>
-            <a:r>
-              <a:rPr sz="2250" b="1">
-                <a:solidFill>
-                  <a:srgbClr val="F4F1E7"/>
-                </a:solidFill>
-                <a:latin typeface="Helvetica Neue"/>
-                <a:ea typeface="Helvetica Neue"/>
-                <a:cs typeface="Helvetica Neue"/>
-              </a:rPr>
-              <a:t>In a new session: $pm-help, $grill-me or $pm-start</a:t>
-            </a:r>
-          </a:p>
-        </p:txBody>
-      </p:sp>
-      <p:sp>
-        <p:nvSpPr>
-          <p:cNvPr id="7" name="">
-            <a:extLst xmlns:a="http://schemas.openxmlformats.org/drawingml/2006/main">
-              <a:ext uri="{FF2B5EF4-FFF2-40B4-BE49-F238E27FC236}">
-                <a16:creationId xmlns:a16="http://schemas.microsoft.com/office/drawing/2014/main" id="{55B1F07A-3C5A-4A36-B14D-35FBEA59D868}"/>
-              </a:ext>
-            </a:extLst>
-          </p:cNvPr>
-          <p:cNvSpPr>
-            <a:spLocks xmlns:a="http://schemas.openxmlformats.org/drawingml/2006/main" noGrp="1"/>
-          </p:cNvSpPr>
-          <p:nvPr/>
-        </p:nvSpPr>
-        <p:spPr>
-          <a:xfrm xmlns:a="http://schemas.openxmlformats.org/drawingml/2006/main">
-            <a:off x="619125" y="5191125"/>
-            <a:ext cx="10668000" cy="466725"/>
-          </a:xfrm>
-          <a:prstGeom xmlns:a="http://schemas.openxmlformats.org/drawingml/2006/main" prst="rect">
-            <a:avLst/>
-          </a:prstGeom>
-          <a:noFill xmlns:a="http://schemas.openxmlformats.org/drawingml/2006/main"/>
-          <a:ln xmlns:a="http://schemas.openxmlformats.org/drawingml/2006/main" w="0">
-            <a:noFill/>
-          </a:ln>
-        </p:spPr>
-        <p:txBody>
-          <a:bodyPr xmlns:a="http://schemas.openxmlformats.org/drawingml/2006/main">
-            <a:noAutofit/>
-          </a:bodyPr>
-          <a:lstStyle xmlns:a="http://schemas.openxmlformats.org/drawingml/2006/main"/>
-          <a:p xmlns:a="http://schemas.openxmlformats.org/drawingml/2006/main">
-            <a:pPr>
-              <a:defRPr sz="1950" b="0">
-                <a:solidFill>
-                  <a:srgbClr val="D8E5DA"/>
-                </a:solidFill>
-                <a:latin typeface="Helvetica Neue"/>
-                <a:ea typeface="Helvetica Neue"/>
-                <a:cs typeface="Helvetica Neue"/>
-              </a:defRPr>
-            </a:pPr>
-            <a:r>
-              <a:rPr sz="1950" b="0">
-                <a:solidFill>
-                  <a:srgbClr val="D8E5DA"/>
-                </a:solidFill>
-                <a:latin typeface="Helvetica Neue"/>
-                <a:ea typeface="Helvetica Neue"/>
-                <a:cs typeface="Helvetica Neue"/>
-              </a:rPr>
-              <a:t>Claude Code installation and prerequisites in the repository</a:t>
-            </a:r>
-          </a:p>
-        </p:txBody>
-      </p:sp>
-      <p:sp>
-        <p:nvSpPr>
-          <p:cNvPr id="8" name="">
-            <a:extLst xmlns:a="http://schemas.openxmlformats.org/drawingml/2006/main">
-              <a:ext uri="{FF2B5EF4-FFF2-40B4-BE49-F238E27FC236}">
-                <a16:creationId xmlns:a16="http://schemas.microsoft.com/office/drawing/2014/main" id="{83A061B8-2747-4A48-8843-9BE4BFC1A1B7}"/>
-              </a:ext>
-            </a:extLst>
-          </p:cNvPr>
-          <p:cNvSpPr>
-            <a:spLocks xmlns:a="http://schemas.openxmlformats.org/drawingml/2006/main" noGrp="1"/>
-          </p:cNvSpPr>
-          <p:nvPr/>
-        </p:nvSpPr>
-        <p:spPr>
-          <a:xfrm xmlns:a="http://schemas.openxmlformats.org/drawingml/2006/main">
-            <a:off x="619125" y="5962650"/>
-            <a:ext cx="10668000" cy="304800"/>
-          </a:xfrm>
-          <a:prstGeom xmlns:a="http://schemas.openxmlformats.org/drawingml/2006/main" prst="rect">
-            <a:avLst/>
-          </a:prstGeom>
-          <a:noFill xmlns:a="http://schemas.openxmlformats.org/drawingml/2006/main"/>
-          <a:ln xmlns:a="http://schemas.openxmlformats.org/drawingml/2006/main" w="0">
-            <a:noFill/>
-          </a:ln>
-        </p:spPr>
-        <p:txBody>
-          <a:bodyPr xmlns:a="http://schemas.openxmlformats.org/drawingml/2006/main">
-            <a:noAutofit/>
-          </a:bodyPr>
-          <a:lstStyle xmlns:a="http://schemas.openxmlformats.org/drawingml/2006/main"/>
-          <a:p xmlns:a="http://schemas.openxmlformats.org/drawingml/2006/main">
-            <a:pPr>
-              <a:defRPr sz="1650" b="0">
-                <a:solidFill>
-                  <a:srgbClr val="D8E5DA"/>
-                </a:solidFill>
-                <a:latin typeface="Helvetica Neue"/>
-                <a:ea typeface="Helvetica Neue"/>
-                <a:cs typeface="Helvetica Neue"/>
-              </a:defRPr>
-            </a:pPr>
-            <a:r>
-              <a:rPr sz="1650" b="0">
-                <a:solidFill>
-                  <a:srgbClr val="D8E5DA"/>
-                </a:solidFill>
-                <a:latin typeface="Helvetica Neue"/>
-                <a:ea typeface="Helvetica Neue"/>
-                <a:cs typeface="Helvetica Neue"/>
-              </a:rPr>
-              <a:t>Assignment 4 - Vandana Ajay Dubey C51</a:t>
-            </a:r>
-          </a:p>
-        </p:txBody>
-      </p:sp>
-    </p:spTree>
-    <p:extLst>
-      <p:ext uri="{BB962C8B-B14F-4D97-AF65-F5344CB8AC3E}">
-        <p14:creationId xmlns:p14="http://schemas.microsoft.com/office/powerpoint/2010/main" val="1288173871"/>
+        <p14:creationId xmlns:p14="http://schemas.microsoft.com/office/powerpoint/2010/main" val="1204166806"/>
       </p:ext>
     </p:extLst>
   </p:cSld>
@@ -4498,7 +2660,7 @@
           <p:cNvPr id="10" name="">
             <a:extLst xmlns:a="http://schemas.openxmlformats.org/drawingml/2006/main">
               <a:ext uri="{FF2B5EF4-FFF2-40B4-BE49-F238E27FC236}">
-                <a16:creationId xmlns:a16="http://schemas.microsoft.com/office/drawing/2014/main" id="{9E21CA7F-8F8C-45DF-B8B0-30CBF3C6DB1F}"/>
+                <a16:creationId xmlns:a16="http://schemas.microsoft.com/office/drawing/2014/main" id="{800A070C-8089-467E-8B13-E46BEDA1F3C8}"/>
               </a:ext>
             </a:extLst>
           </p:cNvPr>
@@ -4555,7 +2717,7 @@
           <p:cNvPr id="2" name="">
             <a:extLst xmlns:a="http://schemas.openxmlformats.org/drawingml/2006/main">
               <a:ext uri="{FF2B5EF4-FFF2-40B4-BE49-F238E27FC236}">
-                <a16:creationId xmlns:a16="http://schemas.microsoft.com/office/drawing/2014/main" id="{D498DBA8-18E5-4FAB-9E38-CC27D4EE804D}"/>
+                <a16:creationId xmlns:a16="http://schemas.microsoft.com/office/drawing/2014/main" id="{C898D014-6037-4673-8D51-F5048CFEAADE}"/>
               </a:ext>
             </a:extLst>
           </p:cNvPr>
@@ -4612,7 +2774,7 @@
           <p:cNvPr id="3" name="">
             <a:extLst xmlns:a="http://schemas.openxmlformats.org/drawingml/2006/main">
               <a:ext uri="{FF2B5EF4-FFF2-40B4-BE49-F238E27FC236}">
-                <a16:creationId xmlns:a16="http://schemas.microsoft.com/office/drawing/2014/main" id="{161F0384-E8A2-4172-A8C0-A081093F4B22}"/>
+                <a16:creationId xmlns:a16="http://schemas.microsoft.com/office/drawing/2014/main" id="{C1E5693E-3EB1-4C2E-9F60-5A4B852124D4}"/>
               </a:ext>
             </a:extLst>
           </p:cNvPr>
@@ -4669,7 +2831,7 @@
           <p:cNvPr id="4" name="">
             <a:extLst xmlns:a="http://schemas.openxmlformats.org/drawingml/2006/main">
               <a:ext uri="{FF2B5EF4-FFF2-40B4-BE49-F238E27FC236}">
-                <a16:creationId xmlns:a16="http://schemas.microsoft.com/office/drawing/2014/main" id="{8369E5FC-97C0-4322-B1D6-93206CF9B5EC}"/>
+                <a16:creationId xmlns:a16="http://schemas.microsoft.com/office/drawing/2014/main" id="{FD2E8BC5-4321-47DB-8C27-734AD118E911}"/>
               </a:ext>
             </a:extLst>
           </p:cNvPr>
@@ -4749,7 +2911,7 @@
           <p:cNvPr id="5" name="">
             <a:extLst xmlns:a="http://schemas.openxmlformats.org/drawingml/2006/main">
               <a:ext uri="{FF2B5EF4-FFF2-40B4-BE49-F238E27FC236}">
-                <a16:creationId xmlns:a16="http://schemas.microsoft.com/office/drawing/2014/main" id="{9E1AEC43-75EB-4A41-9341-6609C66FFC86}"/>
+                <a16:creationId xmlns:a16="http://schemas.microsoft.com/office/drawing/2014/main" id="{85DC9A71-B7C0-4730-830D-B595EF14BDDF}"/>
               </a:ext>
             </a:extLst>
           </p:cNvPr>
@@ -4806,7 +2968,7 @@
           <p:cNvPr id="6" name="">
             <a:extLst xmlns:a="http://schemas.openxmlformats.org/drawingml/2006/main">
               <a:ext uri="{FF2B5EF4-FFF2-40B4-BE49-F238E27FC236}">
-                <a16:creationId xmlns:a16="http://schemas.microsoft.com/office/drawing/2014/main" id="{7C47FF07-6BE5-417C-990C-13E91962874D}"/>
+                <a16:creationId xmlns:a16="http://schemas.microsoft.com/office/drawing/2014/main" id="{8D93F47A-EFD7-4A47-B21D-D2919963D3BF}"/>
               </a:ext>
             </a:extLst>
           </p:cNvPr>
@@ -4863,7 +3025,7 @@
           <p:cNvPr id="7" name="">
             <a:extLst xmlns:a="http://schemas.openxmlformats.org/drawingml/2006/main">
               <a:ext uri="{FF2B5EF4-FFF2-40B4-BE49-F238E27FC236}">
-                <a16:creationId xmlns:a16="http://schemas.microsoft.com/office/drawing/2014/main" id="{FB5F6EC1-03CA-4C22-9B61-E5D35E470F0C}"/>
+                <a16:creationId xmlns:a16="http://schemas.microsoft.com/office/drawing/2014/main" id="{CAB941BE-A64C-4F60-A57F-266354980F7E}"/>
               </a:ext>
             </a:extLst>
           </p:cNvPr>
@@ -4920,7 +3082,7 @@
           <p:cNvPr id="8" name="">
             <a:extLst xmlns:a="http://schemas.openxmlformats.org/drawingml/2006/main">
               <a:ext uri="{FF2B5EF4-FFF2-40B4-BE49-F238E27FC236}">
-                <a16:creationId xmlns:a16="http://schemas.microsoft.com/office/drawing/2014/main" id="{094AF4D4-2971-46F8-8E1F-4E5C64AF21F4}"/>
+                <a16:creationId xmlns:a16="http://schemas.microsoft.com/office/drawing/2014/main" id="{A078E047-2D46-49B9-896E-3686F2F5E75E}"/>
               </a:ext>
             </a:extLst>
           </p:cNvPr>
@@ -4977,7 +3139,7 @@
           <p:cNvPr id="9" name="">
             <a:extLst xmlns:a="http://schemas.openxmlformats.org/drawingml/2006/main">
               <a:ext uri="{FF2B5EF4-FFF2-40B4-BE49-F238E27FC236}">
-                <a16:creationId xmlns:a16="http://schemas.microsoft.com/office/drawing/2014/main" id="{7A7F5116-291E-4041-BC6E-706855E895E4}"/>
+                <a16:creationId xmlns:a16="http://schemas.microsoft.com/office/drawing/2014/main" id="{EEAA6570-2499-442D-8A81-3F2162FED5A3}"/>
               </a:ext>
             </a:extLst>
           </p:cNvPr>
@@ -5032,7 +3194,7 @@
     </p:spTree>
     <p:extLst>
       <p:ext uri="{BB962C8B-B14F-4D97-AF65-F5344CB8AC3E}">
-        <p14:creationId xmlns:p14="http://schemas.microsoft.com/office/powerpoint/2010/main" val="918199505"/>
+        <p14:creationId xmlns:p14="http://schemas.microsoft.com/office/powerpoint/2010/main" val="611607339"/>
       </p:ext>
     </p:extLst>
   </p:cSld>
@@ -5063,7 +3225,7 @@
           <p:cNvPr id="7" name="">
             <a:extLst xmlns:a="http://schemas.openxmlformats.org/drawingml/2006/main">
               <a:ext uri="{FF2B5EF4-FFF2-40B4-BE49-F238E27FC236}">
-                <a16:creationId xmlns:a16="http://schemas.microsoft.com/office/drawing/2014/main" id="{7B27EE2C-6E34-4FB3-88B0-D5A1F573D723}"/>
+                <a16:creationId xmlns:a16="http://schemas.microsoft.com/office/drawing/2014/main" id="{90036331-0ED2-4A6F-9ABC-FE0D5AE926E4}"/>
               </a:ext>
             </a:extLst>
           </p:cNvPr>
@@ -5120,7 +3282,7 @@
           <p:cNvPr id="2" name="">
             <a:extLst xmlns:a="http://schemas.openxmlformats.org/drawingml/2006/main">
               <a:ext uri="{FF2B5EF4-FFF2-40B4-BE49-F238E27FC236}">
-                <a16:creationId xmlns:a16="http://schemas.microsoft.com/office/drawing/2014/main" id="{F5A3A3CF-2EF0-4EC2-B957-B6D68EB3BB20}"/>
+                <a16:creationId xmlns:a16="http://schemas.microsoft.com/office/drawing/2014/main" id="{1E8EBB4F-3BCE-47AC-ACFC-9A62A22F8F33}"/>
               </a:ext>
             </a:extLst>
           </p:cNvPr>
@@ -5177,7 +3339,7 @@
           <p:cNvPr id="3" name="">
             <a:extLst xmlns:a="http://schemas.openxmlformats.org/drawingml/2006/main">
               <a:ext uri="{FF2B5EF4-FFF2-40B4-BE49-F238E27FC236}">
-                <a16:creationId xmlns:a16="http://schemas.microsoft.com/office/drawing/2014/main" id="{CDF44815-CDD4-442E-A02F-712725084050}"/>
+                <a16:creationId xmlns:a16="http://schemas.microsoft.com/office/drawing/2014/main" id="{8720B7E4-5BF1-489C-8424-E93E7104AA63}"/>
               </a:ext>
             </a:extLst>
           </p:cNvPr>
@@ -5234,7 +3396,7 @@
           <p:cNvPr id="4" name="">
             <a:extLst xmlns:a="http://schemas.openxmlformats.org/drawingml/2006/main">
               <a:ext uri="{FF2B5EF4-FFF2-40B4-BE49-F238E27FC236}">
-                <a16:creationId xmlns:a16="http://schemas.microsoft.com/office/drawing/2014/main" id="{22C3969E-A535-42A9-8E49-E14995AC945E}"/>
+                <a16:creationId xmlns:a16="http://schemas.microsoft.com/office/drawing/2014/main" id="{C56F52E9-B5F1-4925-9300-0667562EAA06}"/>
               </a:ext>
             </a:extLst>
           </p:cNvPr>
@@ -5576,7 +3738,7 @@
           <p:cNvPr id="6" name="">
             <a:extLst xmlns:a="http://schemas.openxmlformats.org/drawingml/2006/main">
               <a:ext uri="{FF2B5EF4-FFF2-40B4-BE49-F238E27FC236}">
-                <a16:creationId xmlns:a16="http://schemas.microsoft.com/office/drawing/2014/main" id="{15C86449-969A-4BFF-9F98-278DA0E69F15}"/>
+                <a16:creationId xmlns:a16="http://schemas.microsoft.com/office/drawing/2014/main" id="{C960D7AC-69CF-460B-843B-96D73E554D84}"/>
               </a:ext>
             </a:extLst>
           </p:cNvPr>
@@ -5631,7 +3793,7 @@
     </p:spTree>
     <p:extLst>
       <p:ext uri="{BB962C8B-B14F-4D97-AF65-F5344CB8AC3E}">
-        <p14:creationId xmlns:p14="http://schemas.microsoft.com/office/powerpoint/2010/main" val="1778167638"/>
+        <p14:creationId xmlns:p14="http://schemas.microsoft.com/office/powerpoint/2010/main" val="804709450"/>
       </p:ext>
     </p:extLst>
   </p:cSld>
@@ -5662,7 +3824,7 @@
           <p:cNvPr id="5" name="">
             <a:extLst xmlns:a="http://schemas.openxmlformats.org/drawingml/2006/main">
               <a:ext uri="{FF2B5EF4-FFF2-40B4-BE49-F238E27FC236}">
-                <a16:creationId xmlns:a16="http://schemas.microsoft.com/office/drawing/2014/main" id="{FA15886D-27EE-40AD-84B8-AD2CB5A3A705}"/>
+                <a16:creationId xmlns:a16="http://schemas.microsoft.com/office/drawing/2014/main" id="{4CFBF3A3-73EB-49AE-B0DF-76AB18DB542D}"/>
               </a:ext>
             </a:extLst>
           </p:cNvPr>
@@ -5719,7 +3881,7 @@
           <p:cNvPr id="2" name="">
             <a:extLst xmlns:a="http://schemas.openxmlformats.org/drawingml/2006/main">
               <a:ext uri="{FF2B5EF4-FFF2-40B4-BE49-F238E27FC236}">
-                <a16:creationId xmlns:a16="http://schemas.microsoft.com/office/drawing/2014/main" id="{CA6BD071-A25A-40D2-BD3A-7BBA584B430C}"/>
+                <a16:creationId xmlns:a16="http://schemas.microsoft.com/office/drawing/2014/main" id="{7DE381E4-3A89-4FA2-B0EC-0961E0DBCE8C}"/>
               </a:ext>
             </a:extLst>
           </p:cNvPr>
@@ -6359,7 +4521,7 @@
           <p:cNvPr id="4" name="">
             <a:extLst xmlns:a="http://schemas.openxmlformats.org/drawingml/2006/main">
               <a:ext uri="{FF2B5EF4-FFF2-40B4-BE49-F238E27FC236}">
-                <a16:creationId xmlns:a16="http://schemas.microsoft.com/office/drawing/2014/main" id="{81AFE677-0ACE-47C9-8AA7-452796BFC4D2}"/>
+                <a16:creationId xmlns:a16="http://schemas.microsoft.com/office/drawing/2014/main" id="{082B51D5-DB19-45F4-B762-0DAE953BDD77}"/>
               </a:ext>
             </a:extLst>
           </p:cNvPr>
@@ -6414,7 +4576,7 @@
     </p:spTree>
     <p:extLst>
       <p:ext uri="{BB962C8B-B14F-4D97-AF65-F5344CB8AC3E}">
-        <p14:creationId xmlns:p14="http://schemas.microsoft.com/office/powerpoint/2010/main" val="1461493520"/>
+        <p14:creationId xmlns:p14="http://schemas.microsoft.com/office/powerpoint/2010/main" val="1533693601"/>
       </p:ext>
     </p:extLst>
   </p:cSld>
@@ -6445,7 +4607,7 @@
           <p:cNvPr id="10" name="">
             <a:extLst xmlns:a="http://schemas.openxmlformats.org/drawingml/2006/main">
               <a:ext uri="{FF2B5EF4-FFF2-40B4-BE49-F238E27FC236}">
-                <a16:creationId xmlns:a16="http://schemas.microsoft.com/office/drawing/2014/main" id="{1EB21F17-7879-4928-9930-00D9BCBBFDD2}"/>
+                <a16:creationId xmlns:a16="http://schemas.microsoft.com/office/drawing/2014/main" id="{6AC6B0A3-7F86-487C-A30B-B6447662E3C4}"/>
               </a:ext>
             </a:extLst>
           </p:cNvPr>
@@ -6502,7 +4664,7 @@
           <p:cNvPr id="2" name="">
             <a:extLst xmlns:a="http://schemas.openxmlformats.org/drawingml/2006/main">
               <a:ext uri="{FF2B5EF4-FFF2-40B4-BE49-F238E27FC236}">
-                <a16:creationId xmlns:a16="http://schemas.microsoft.com/office/drawing/2014/main" id="{14F52E78-D44E-4509-A605-6D80430395AA}"/>
+                <a16:creationId xmlns:a16="http://schemas.microsoft.com/office/drawing/2014/main" id="{005D8FFE-2FFB-4BA2-88A5-E7AD7B28FF34}"/>
               </a:ext>
             </a:extLst>
           </p:cNvPr>
@@ -6559,7 +4721,7 @@
           <p:cNvPr id="3" name="">
             <a:extLst xmlns:a="http://schemas.openxmlformats.org/drawingml/2006/main">
               <a:ext uri="{FF2B5EF4-FFF2-40B4-BE49-F238E27FC236}">
-                <a16:creationId xmlns:a16="http://schemas.microsoft.com/office/drawing/2014/main" id="{A34135B7-E407-4E9E-B66C-D04197C23FA1}"/>
+                <a16:creationId xmlns:a16="http://schemas.microsoft.com/office/drawing/2014/main" id="{FA603A4C-9648-4A14-AB11-168267E3DB52}"/>
               </a:ext>
             </a:extLst>
           </p:cNvPr>
@@ -6616,7 +4778,7 @@
           <p:cNvPr id="4" name="">
             <a:extLst xmlns:a="http://schemas.openxmlformats.org/drawingml/2006/main">
               <a:ext uri="{FF2B5EF4-FFF2-40B4-BE49-F238E27FC236}">
-                <a16:creationId xmlns:a16="http://schemas.microsoft.com/office/drawing/2014/main" id="{80C5D811-D7A2-40D9-B51C-7F33A94B85BB}"/>
+                <a16:creationId xmlns:a16="http://schemas.microsoft.com/office/drawing/2014/main" id="{1D73210D-D12B-4D71-955B-7296F3BE6D7E}"/>
               </a:ext>
             </a:extLst>
           </p:cNvPr>
@@ -6673,7 +4835,7 @@
           <p:cNvPr id="5" name="">
             <a:extLst xmlns:a="http://schemas.openxmlformats.org/drawingml/2006/main">
               <a:ext uri="{FF2B5EF4-FFF2-40B4-BE49-F238E27FC236}">
-                <a16:creationId xmlns:a16="http://schemas.microsoft.com/office/drawing/2014/main" id="{1DE7F049-3945-4B4C-ADC6-1449F68AAD30}"/>
+                <a16:creationId xmlns:a16="http://schemas.microsoft.com/office/drawing/2014/main" id="{1D8700E1-965D-4D2E-970B-68EA4AD32A79}"/>
               </a:ext>
             </a:extLst>
           </p:cNvPr>
@@ -6730,7 +4892,7 @@
           <p:cNvPr id="6" name="">
             <a:extLst xmlns:a="http://schemas.openxmlformats.org/drawingml/2006/main">
               <a:ext uri="{FF2B5EF4-FFF2-40B4-BE49-F238E27FC236}">
-                <a16:creationId xmlns:a16="http://schemas.microsoft.com/office/drawing/2014/main" id="{D673B51D-C28C-43D7-AE84-E0915323128F}"/>
+                <a16:creationId xmlns:a16="http://schemas.microsoft.com/office/drawing/2014/main" id="{01B09C34-675E-4226-B55B-DDABC91B50FC}"/>
               </a:ext>
             </a:extLst>
           </p:cNvPr>
@@ -6787,7 +4949,7 @@
           <p:cNvPr id="7" name="">
             <a:extLst xmlns:a="http://schemas.openxmlformats.org/drawingml/2006/main">
               <a:ext uri="{FF2B5EF4-FFF2-40B4-BE49-F238E27FC236}">
-                <a16:creationId xmlns:a16="http://schemas.microsoft.com/office/drawing/2014/main" id="{7041E185-A7CE-4E81-8BB5-E200A5E4F0E4}"/>
+                <a16:creationId xmlns:a16="http://schemas.microsoft.com/office/drawing/2014/main" id="{8F39BD1E-DDE5-4B69-B4C9-826B977A5D4C}"/>
               </a:ext>
             </a:extLst>
           </p:cNvPr>
@@ -6844,7 +5006,7 @@
           <p:cNvPr id="8" name="">
             <a:extLst xmlns:a="http://schemas.openxmlformats.org/drawingml/2006/main">
               <a:ext uri="{FF2B5EF4-FFF2-40B4-BE49-F238E27FC236}">
-                <a16:creationId xmlns:a16="http://schemas.microsoft.com/office/drawing/2014/main" id="{606F8BA2-6D8B-4109-9C23-6A1A1B168D61}"/>
+                <a16:creationId xmlns:a16="http://schemas.microsoft.com/office/drawing/2014/main" id="{6D190752-014E-47A5-8B39-555FD4AF9F1D}"/>
               </a:ext>
             </a:extLst>
           </p:cNvPr>
@@ -6947,7 +5109,7 @@
           <p:cNvPr id="9" name="">
             <a:extLst xmlns:a="http://schemas.openxmlformats.org/drawingml/2006/main">
               <a:ext uri="{FF2B5EF4-FFF2-40B4-BE49-F238E27FC236}">
-                <a16:creationId xmlns:a16="http://schemas.microsoft.com/office/drawing/2014/main" id="{079CAA76-1097-4CE9-8612-4B4ADE14D7DD}"/>
+                <a16:creationId xmlns:a16="http://schemas.microsoft.com/office/drawing/2014/main" id="{42C39FF1-2595-43B4-9AA3-98F4F4704C75}"/>
               </a:ext>
             </a:extLst>
           </p:cNvPr>
@@ -7025,7 +5187,7 @@
     </p:spTree>
     <p:extLst>
       <p:ext uri="{BB962C8B-B14F-4D97-AF65-F5344CB8AC3E}">
-        <p14:creationId xmlns:p14="http://schemas.microsoft.com/office/powerpoint/2010/main" val="246550880"/>
+        <p14:creationId xmlns:p14="http://schemas.microsoft.com/office/powerpoint/2010/main" val="1045182101"/>
       </p:ext>
     </p:extLst>
   </p:cSld>
@@ -7056,7 +5218,7 @@
           <p:cNvPr id="7" name="">
             <a:extLst xmlns:a="http://schemas.openxmlformats.org/drawingml/2006/main">
               <a:ext uri="{FF2B5EF4-FFF2-40B4-BE49-F238E27FC236}">
-                <a16:creationId xmlns:a16="http://schemas.microsoft.com/office/drawing/2014/main" id="{69A533B1-1EEF-4ADC-829C-CB3A18AE5B3A}"/>
+                <a16:creationId xmlns:a16="http://schemas.microsoft.com/office/drawing/2014/main" id="{F6B0B012-433D-41C9-B5A5-A116474BEEB7}"/>
               </a:ext>
             </a:extLst>
           </p:cNvPr>
@@ -7113,7 +5275,7 @@
           <p:cNvPr id="2" name="">
             <a:extLst xmlns:a="http://schemas.openxmlformats.org/drawingml/2006/main">
               <a:ext uri="{FF2B5EF4-FFF2-40B4-BE49-F238E27FC236}">
-                <a16:creationId xmlns:a16="http://schemas.microsoft.com/office/drawing/2014/main" id="{861C7BBF-3885-4D05-8D23-90AD21E959EC}"/>
+                <a16:creationId xmlns:a16="http://schemas.microsoft.com/office/drawing/2014/main" id="{7F3CD30B-6772-450D-8725-8BE416410AA7}"/>
               </a:ext>
             </a:extLst>
           </p:cNvPr>
@@ -7170,7 +5332,7 @@
           <p:cNvPr id="3" name="">
             <a:extLst xmlns:a="http://schemas.openxmlformats.org/drawingml/2006/main">
               <a:ext uri="{FF2B5EF4-FFF2-40B4-BE49-F238E27FC236}">
-                <a16:creationId xmlns:a16="http://schemas.microsoft.com/office/drawing/2014/main" id="{3E91AF22-7DD2-4CD5-861E-CBF7726ED337}"/>
+                <a16:creationId xmlns:a16="http://schemas.microsoft.com/office/drawing/2014/main" id="{6D827284-C22D-4A82-9DA3-70AB3465EB22}"/>
               </a:ext>
             </a:extLst>
           </p:cNvPr>
@@ -7227,7 +5389,7 @@
           <p:cNvPr id="4" name="">
             <a:extLst xmlns:a="http://schemas.openxmlformats.org/drawingml/2006/main">
               <a:ext uri="{FF2B5EF4-FFF2-40B4-BE49-F238E27FC236}">
-                <a16:creationId xmlns:a16="http://schemas.microsoft.com/office/drawing/2014/main" id="{AA438D58-33F6-4AF0-8080-DE1CA6650C30}"/>
+                <a16:creationId xmlns:a16="http://schemas.microsoft.com/office/drawing/2014/main" id="{5404CD3C-BD15-451A-BB7D-E95DE1A8EC90}"/>
               </a:ext>
             </a:extLst>
           </p:cNvPr>
@@ -7330,7 +5492,7 @@
           <p:cNvPr id="5" name="">
             <a:extLst xmlns:a="http://schemas.openxmlformats.org/drawingml/2006/main">
               <a:ext uri="{FF2B5EF4-FFF2-40B4-BE49-F238E27FC236}">
-                <a16:creationId xmlns:a16="http://schemas.microsoft.com/office/drawing/2014/main" id="{B050C199-7429-4C99-98BC-BA79A15A230B}"/>
+                <a16:creationId xmlns:a16="http://schemas.microsoft.com/office/drawing/2014/main" id="{FB944DAF-EFAE-4C97-82F1-6AD6E8A88205}"/>
               </a:ext>
             </a:extLst>
           </p:cNvPr>
@@ -7414,7 +5576,7 @@
           <p:nvPr/>
         </p:nvPicPr>
         <p:blipFill>
-          <a:blip xmlns:r="http://schemas.openxmlformats.org/officeDocument/2006/relationships" xmlns:a="http://schemas.openxmlformats.org/drawingml/2006/main" r:embed="R69e4e66d3f074ff8"/>
+          <a:blip xmlns:r="http://schemas.openxmlformats.org/officeDocument/2006/relationships" xmlns:a="http://schemas.openxmlformats.org/drawingml/2006/main" r:embed="R1227fa6efd974bd2"/>
           <a:stretch xmlns:a="http://schemas.openxmlformats.org/drawingml/2006/main"/>
         </p:blipFill>
         <p:spPr>
@@ -7430,7 +5592,7 @@
     </p:spTree>
     <p:extLst>
       <p:ext uri="{BB962C8B-B14F-4D97-AF65-F5344CB8AC3E}">
-        <p14:creationId xmlns:p14="http://schemas.microsoft.com/office/powerpoint/2010/main" val="915068125"/>
+        <p14:creationId xmlns:p14="http://schemas.microsoft.com/office/powerpoint/2010/main" val="1426795615"/>
       </p:ext>
     </p:extLst>
   </p:cSld>
@@ -7461,7 +5623,7 @@
           <p:cNvPr id="5" name="">
             <a:extLst xmlns:a="http://schemas.openxmlformats.org/drawingml/2006/main">
               <a:ext uri="{FF2B5EF4-FFF2-40B4-BE49-F238E27FC236}">
-                <a16:creationId xmlns:a16="http://schemas.microsoft.com/office/drawing/2014/main" id="{F2DBA85B-26AE-4D7F-90EF-15AAB6F07723}"/>
+                <a16:creationId xmlns:a16="http://schemas.microsoft.com/office/drawing/2014/main" id="{9D0BEA14-EED0-422C-8296-ED51705D7CFB}"/>
               </a:ext>
             </a:extLst>
           </p:cNvPr>
@@ -7518,7 +5680,7 @@
           <p:cNvPr id="2" name="">
             <a:extLst xmlns:a="http://schemas.openxmlformats.org/drawingml/2006/main">
               <a:ext uri="{FF2B5EF4-FFF2-40B4-BE49-F238E27FC236}">
-                <a16:creationId xmlns:a16="http://schemas.microsoft.com/office/drawing/2014/main" id="{915FB0B6-BC4B-481D-919D-2EB0BE0D0215}"/>
+                <a16:creationId xmlns:a16="http://schemas.microsoft.com/office/drawing/2014/main" id="{93A26CA5-D5D0-44B1-8A0D-36D688CC4AC2}"/>
               </a:ext>
             </a:extLst>
           </p:cNvPr>
@@ -8078,7 +6240,7 @@
           <p:cNvPr id="4" name="">
             <a:extLst xmlns:a="http://schemas.openxmlformats.org/drawingml/2006/main">
               <a:ext uri="{FF2B5EF4-FFF2-40B4-BE49-F238E27FC236}">
-                <a16:creationId xmlns:a16="http://schemas.microsoft.com/office/drawing/2014/main" id="{C1303C59-92B5-45B9-BCBA-89095B5737FE}"/>
+                <a16:creationId xmlns:a16="http://schemas.microsoft.com/office/drawing/2014/main" id="{119F39CC-B9E9-4625-BD23-9E725F18D07A}"/>
               </a:ext>
             </a:extLst>
           </p:cNvPr>
@@ -8156,7 +6318,7 @@
     </p:spTree>
     <p:extLst>
       <p:ext uri="{BB962C8B-B14F-4D97-AF65-F5344CB8AC3E}">
-        <p14:creationId xmlns:p14="http://schemas.microsoft.com/office/powerpoint/2010/main" val="1518289091"/>
+        <p14:creationId xmlns:p14="http://schemas.microsoft.com/office/powerpoint/2010/main" val="508033769"/>
       </p:ext>
     </p:extLst>
   </p:cSld>
@@ -8187,7 +6349,7 @@
           <p:cNvPr id="7" name="">
             <a:extLst xmlns:a="http://schemas.openxmlformats.org/drawingml/2006/main">
               <a:ext uri="{FF2B5EF4-FFF2-40B4-BE49-F238E27FC236}">
-                <a16:creationId xmlns:a16="http://schemas.microsoft.com/office/drawing/2014/main" id="{9AC45124-9766-4632-B1C6-87BD65A9F7EF}"/>
+                <a16:creationId xmlns:a16="http://schemas.microsoft.com/office/drawing/2014/main" id="{1AD6B726-F971-424B-A189-446590E22DD3}"/>
               </a:ext>
             </a:extLst>
           </p:cNvPr>
@@ -8244,7 +6406,7 @@
           <p:cNvPr id="2" name="">
             <a:extLst xmlns:a="http://schemas.openxmlformats.org/drawingml/2006/main">
               <a:ext uri="{FF2B5EF4-FFF2-40B4-BE49-F238E27FC236}">
-                <a16:creationId xmlns:a16="http://schemas.microsoft.com/office/drawing/2014/main" id="{BBF1B64E-1BF1-4BE8-9578-0E0975689501}"/>
+                <a16:creationId xmlns:a16="http://schemas.microsoft.com/office/drawing/2014/main" id="{05090E63-F37C-4000-AB74-B0A4C795EB21}"/>
               </a:ext>
             </a:extLst>
           </p:cNvPr>
@@ -8301,7 +6463,7 @@
           <p:cNvPr id="3" name="">
             <a:extLst xmlns:a="http://schemas.openxmlformats.org/drawingml/2006/main">
               <a:ext uri="{FF2B5EF4-FFF2-40B4-BE49-F238E27FC236}">
-                <a16:creationId xmlns:a16="http://schemas.microsoft.com/office/drawing/2014/main" id="{E2F222D4-0E88-4291-A079-C0CE2E9F5957}"/>
+                <a16:creationId xmlns:a16="http://schemas.microsoft.com/office/drawing/2014/main" id="{B1DD82B5-7CE6-421B-BFB4-D7C2FC0737AD}"/>
               </a:ext>
             </a:extLst>
           </p:cNvPr>
@@ -8596,7 +6758,7 @@
           <p:cNvPr id="5" name="">
             <a:extLst xmlns:a="http://schemas.openxmlformats.org/drawingml/2006/main">
               <a:ext uri="{FF2B5EF4-FFF2-40B4-BE49-F238E27FC236}">
-                <a16:creationId xmlns:a16="http://schemas.microsoft.com/office/drawing/2014/main" id="{C8D4B8DA-0DB1-4BC7-A05B-EA5629916916}"/>
+                <a16:creationId xmlns:a16="http://schemas.microsoft.com/office/drawing/2014/main" id="{F6B0B2A0-A152-40E4-A9F6-25654F402EE9}"/>
               </a:ext>
             </a:extLst>
           </p:cNvPr>
@@ -8653,7 +6815,7 @@
           <p:cNvPr id="6" name="">
             <a:extLst xmlns:a="http://schemas.openxmlformats.org/drawingml/2006/main">
               <a:ext uri="{FF2B5EF4-FFF2-40B4-BE49-F238E27FC236}">
-                <a16:creationId xmlns:a16="http://schemas.microsoft.com/office/drawing/2014/main" id="{3033B77C-BE20-4653-A8C2-642D59D3DEF1}"/>
+                <a16:creationId xmlns:a16="http://schemas.microsoft.com/office/drawing/2014/main" id="{A4923702-AD6B-4B1A-90C0-B15137B3DE54}"/>
               </a:ext>
             </a:extLst>
           </p:cNvPr>
@@ -8708,7 +6870,7 @@
     </p:spTree>
     <p:extLst>
       <p:ext uri="{BB962C8B-B14F-4D97-AF65-F5344CB8AC3E}">
-        <p14:creationId xmlns:p14="http://schemas.microsoft.com/office/powerpoint/2010/main" val="39565533"/>
+        <p14:creationId xmlns:p14="http://schemas.microsoft.com/office/powerpoint/2010/main" val="915232251"/>
       </p:ext>
     </p:extLst>
   </p:cSld>
@@ -8739,7 +6901,7 @@
           <p:cNvPr id="6" name="">
             <a:extLst xmlns:a="http://schemas.openxmlformats.org/drawingml/2006/main">
               <a:ext uri="{FF2B5EF4-FFF2-40B4-BE49-F238E27FC236}">
-                <a16:creationId xmlns:a16="http://schemas.microsoft.com/office/drawing/2014/main" id="{9F406F13-66F1-4405-8A48-AAC96F8C0147}"/>
+                <a16:creationId xmlns:a16="http://schemas.microsoft.com/office/drawing/2014/main" id="{2D800FCD-845F-4772-AD89-A5E82CE72FEA}"/>
               </a:ext>
             </a:extLst>
           </p:cNvPr>
@@ -8796,7 +6958,7 @@
           <p:cNvPr id="2" name="">
             <a:extLst xmlns:a="http://schemas.openxmlformats.org/drawingml/2006/main">
               <a:ext uri="{FF2B5EF4-FFF2-40B4-BE49-F238E27FC236}">
-                <a16:creationId xmlns:a16="http://schemas.microsoft.com/office/drawing/2014/main" id="{873D8182-9724-4624-B17C-6A58B6CA8824}"/>
+                <a16:creationId xmlns:a16="http://schemas.microsoft.com/office/drawing/2014/main" id="{DAFEB9BF-6B93-4338-A7CB-85110CEC24ED}"/>
               </a:ext>
             </a:extLst>
           </p:cNvPr>
@@ -9130,7 +7292,7 @@
           <p:cNvPr id="4" name="">
             <a:extLst xmlns:a="http://schemas.openxmlformats.org/drawingml/2006/main">
               <a:ext uri="{FF2B5EF4-FFF2-40B4-BE49-F238E27FC236}">
-                <a16:creationId xmlns:a16="http://schemas.microsoft.com/office/drawing/2014/main" id="{F3DEBF87-DE1C-4825-B23E-65A31E8F1638}"/>
+                <a16:creationId xmlns:a16="http://schemas.microsoft.com/office/drawing/2014/main" id="{7218F332-5F5F-45CA-A555-DAC408718D92}"/>
               </a:ext>
             </a:extLst>
           </p:cNvPr>
@@ -9187,7 +7349,7 @@
           <p:cNvPr id="5" name="">
             <a:extLst xmlns:a="http://schemas.openxmlformats.org/drawingml/2006/main">
               <a:ext uri="{FF2B5EF4-FFF2-40B4-BE49-F238E27FC236}">
-                <a16:creationId xmlns:a16="http://schemas.microsoft.com/office/drawing/2014/main" id="{07ABAEFA-B73C-4212-AF6C-928CFD612DF5}"/>
+                <a16:creationId xmlns:a16="http://schemas.microsoft.com/office/drawing/2014/main" id="{466D952F-0551-4A75-BC66-3D7BF9725B1A}"/>
               </a:ext>
             </a:extLst>
           </p:cNvPr>
@@ -9242,7 +7404,7 @@
     </p:spTree>
     <p:extLst>
       <p:ext uri="{BB962C8B-B14F-4D97-AF65-F5344CB8AC3E}">
-        <p14:creationId xmlns:p14="http://schemas.microsoft.com/office/powerpoint/2010/main" val="1437008410"/>
+        <p14:creationId xmlns:p14="http://schemas.microsoft.com/office/powerpoint/2010/main" val="1489173727"/>
       </p:ext>
     </p:extLst>
   </p:cSld>

</xml_diff>